<commit_message>
Fix debt-deck chart labels
</commit_message>
<xml_diff>
--- a/Presentation/7_debt_composition_extension/presentation.pptx
+++ b/Presentation/7_debt_composition_extension/presentation.pptx
@@ -2,17 +2,17 @@
 <file path=ppt/presentation.xml><?xml version="1.0" encoding="utf-8"?>
 <p:presentation xmlns:p="http://schemas.openxmlformats.org/presentationml/2006/main">
   <p:sldMasterIdLst>
-    <p:sldMasterId xmlns:r="http://schemas.openxmlformats.org/officeDocument/2006/relationships" id="2147483648" r:id="Rf50034ac30b349e5"/>
+    <p:sldMasterId xmlns:r="http://schemas.openxmlformats.org/officeDocument/2006/relationships" id="2147483648" r:id="R622cea4c6e9b41c9"/>
   </p:sldMasterIdLst>
   <p:notesMasterIdLst>
-    <p:notesMasterId xmlns:r="http://schemas.openxmlformats.org/officeDocument/2006/relationships" r:id="R3d33d742dea44b78"/>
+    <p:notesMasterId xmlns:r="http://schemas.openxmlformats.org/officeDocument/2006/relationships" r:id="R10a34859d6254419"/>
   </p:notesMasterIdLst>
   <p:sldIdLst>
-    <p:sldId xmlns:r="http://schemas.openxmlformats.org/officeDocument/2006/relationships" id="256" r:id="R7e51e485305d4a3a"/>
-    <p:sldId xmlns:r="http://schemas.openxmlformats.org/officeDocument/2006/relationships" id="257" r:id="R49339656f9424705"/>
-    <p:sldId xmlns:r="http://schemas.openxmlformats.org/officeDocument/2006/relationships" id="258" r:id="Rac2d624e302b4a37"/>
-    <p:sldId xmlns:r="http://schemas.openxmlformats.org/officeDocument/2006/relationships" id="259" r:id="Rc0d8f168089c48a3"/>
-    <p:sldId xmlns:r="http://schemas.openxmlformats.org/officeDocument/2006/relationships" id="260" r:id="R174270711c4b412c"/>
+    <p:sldId xmlns:r="http://schemas.openxmlformats.org/officeDocument/2006/relationships" id="256" r:id="Re8e568bcc2004216"/>
+    <p:sldId xmlns:r="http://schemas.openxmlformats.org/officeDocument/2006/relationships" id="257" r:id="R378bb6fd3b2c4aa7"/>
+    <p:sldId xmlns:r="http://schemas.openxmlformats.org/officeDocument/2006/relationships" id="258" r:id="Rf75c6a25875743fd"/>
+    <p:sldId xmlns:r="http://schemas.openxmlformats.org/officeDocument/2006/relationships" id="259" r:id="R0afb2c5e14a148ab"/>
+    <p:sldId xmlns:r="http://schemas.openxmlformats.org/officeDocument/2006/relationships" id="260" r:id="R8ff50f36e26240bc"/>
   </p:sldIdLst>
   <p:sldSz cx="12192000" cy="6858000"/>
   <p:notesSz cx="6858000" cy="9144000"/>
@@ -919,7 +919,7 @@
   </p:cSld>
   <p:clrMap bg1="lt1" tx1="dk1" bg2="lt2" tx2="dk2" accent1="accent1" accent2="accent2" accent3="accent3" accent4="accent4" accent5="accent5" accent6="accent6" hlink="hlink" folHlink="folHlink"/>
   <p:sldLayoutIdLst>
-    <p:sldLayoutId xmlns:r="http://schemas.openxmlformats.org/officeDocument/2006/relationships" id="2147483649" r:id="Re17d4a5c25474961"/>
+    <p:sldLayoutId xmlns:r="http://schemas.openxmlformats.org/officeDocument/2006/relationships" id="2147483649" r:id="R2da19cacf28d46b7"/>
   </p:sldLayoutIdLst>
   <p:txStyles>
     <p:titleStyle>
@@ -1587,6 +1587,7 @@
         <c:numFmt formatCode="General"/>
         <c:majorTickMark val="none"/>
         <c:minorTickMark val="none"/>
+        <c:tickLblPos val="low"/>
         <c:spPr>
           <a:ln xmlns:a="http://schemas.openxmlformats.org/drawingml/2006/main" w="9525">
             <a:solidFill>
@@ -1873,6 +1874,7 @@
         <c:numFmt formatCode="General"/>
         <c:majorTickMark val="none"/>
         <c:minorTickMark val="none"/>
+        <c:tickLblPos val="low"/>
         <c:spPr>
           <a:ln xmlns:a="http://schemas.openxmlformats.org/drawingml/2006/main" w="9525">
             <a:solidFill>
@@ -2159,6 +2161,7 @@
         <c:numFmt formatCode="General"/>
         <c:majorTickMark val="none"/>
         <c:minorTickMark val="none"/>
+        <c:tickLblPos val="low"/>
         <c:spPr>
           <a:ln xmlns:a="http://schemas.openxmlformats.org/drawingml/2006/main" w="9525">
             <a:solidFill>
@@ -2326,7 +2329,7 @@
           <p:cNvPr id="8" name="title-eyebrow">
             <a:extLst xmlns:a="http://schemas.openxmlformats.org/drawingml/2006/main">
               <a:ext uri="{FF2B5EF4-FFF2-40B4-BE49-F238E27FC236}">
-                <a16:creationId xmlns:a16="http://schemas.microsoft.com/office/drawing/2014/main" id="{99DD95F6-3A5A-4A4C-8A89-ECBD22F61E82}"/>
+                <a16:creationId xmlns:a16="http://schemas.microsoft.com/office/drawing/2014/main" id="{C0F44DB5-748C-4FEB-904C-4A54509DDCA1}"/>
               </a:ext>
             </a:extLst>
           </p:cNvPr>
@@ -2388,7 +2391,7 @@
           <p:cNvPr id="2" name="title-accent">
             <a:extLst xmlns:a="http://schemas.openxmlformats.org/drawingml/2006/main">
               <a:ext uri="{FF2B5EF4-FFF2-40B4-BE49-F238E27FC236}">
-                <a16:creationId xmlns:a16="http://schemas.microsoft.com/office/drawing/2014/main" id="{0854D70F-3EC1-400A-AC56-5218F1C69F65}"/>
+                <a16:creationId xmlns:a16="http://schemas.microsoft.com/office/drawing/2014/main" id="{01EC3742-C838-4B5D-8F91-30E40D76BCEB}"/>
               </a:ext>
             </a:extLst>
           </p:cNvPr>
@@ -2419,7 +2422,7 @@
           <p:cNvPr id="3" name="deck-title">
             <a:extLst xmlns:a="http://schemas.openxmlformats.org/drawingml/2006/main">
               <a:ext uri="{FF2B5EF4-FFF2-40B4-BE49-F238E27FC236}">
-                <a16:creationId xmlns:a16="http://schemas.microsoft.com/office/drawing/2014/main" id="{B30A67FD-614F-42B9-89BC-D1698D560BF5}"/>
+                <a16:creationId xmlns:a16="http://schemas.microsoft.com/office/drawing/2014/main" id="{FE56EFB6-2614-4950-951B-ECB8A9B399F3}"/>
               </a:ext>
             </a:extLst>
           </p:cNvPr>
@@ -2508,7 +2511,7 @@
           <p:cNvPr id="4" name="deck-subtitle">
             <a:extLst xmlns:a="http://schemas.openxmlformats.org/drawingml/2006/main">
               <a:ext uri="{FF2B5EF4-FFF2-40B4-BE49-F238E27FC236}">
-                <a16:creationId xmlns:a16="http://schemas.microsoft.com/office/drawing/2014/main" id="{C39B2A02-1210-47BC-9607-450FCFFB8433}"/>
+                <a16:creationId xmlns:a16="http://schemas.microsoft.com/office/drawing/2014/main" id="{0452BD9A-D1D1-448C-A7A3-DA5DD018AF10}"/>
               </a:ext>
             </a:extLst>
           </p:cNvPr>
@@ -2570,7 +2573,7 @@
           <p:cNvPr id="5" name="deck-boundary">
             <a:extLst xmlns:a="http://schemas.openxmlformats.org/drawingml/2006/main">
               <a:ext uri="{FF2B5EF4-FFF2-40B4-BE49-F238E27FC236}">
-                <a16:creationId xmlns:a16="http://schemas.microsoft.com/office/drawing/2014/main" id="{E3951BE8-5A8B-4B7C-B570-51A9AA1E0451}"/>
+                <a16:creationId xmlns:a16="http://schemas.microsoft.com/office/drawing/2014/main" id="{FF9ED144-0C1C-4FD2-8797-11CFBDD0D9CE}"/>
               </a:ext>
             </a:extLst>
           </p:cNvPr>
@@ -2632,7 +2635,7 @@
           <p:cNvPr id="6" name="title-bottom-rule">
             <a:extLst xmlns:a="http://schemas.openxmlformats.org/drawingml/2006/main">
               <a:ext uri="{FF2B5EF4-FFF2-40B4-BE49-F238E27FC236}">
-                <a16:creationId xmlns:a16="http://schemas.microsoft.com/office/drawing/2014/main" id="{E649021F-0E32-4BB8-8612-E9BA348F7C64}"/>
+                <a16:creationId xmlns:a16="http://schemas.microsoft.com/office/drawing/2014/main" id="{B8B5E906-3E36-49DE-83C3-922BB5206669}"/>
               </a:ext>
             </a:extLst>
           </p:cNvPr>
@@ -2663,7 +2666,7 @@
           <p:cNvPr id="7" name="title-footer">
             <a:extLst xmlns:a="http://schemas.openxmlformats.org/drawingml/2006/main">
               <a:ext uri="{FF2B5EF4-FFF2-40B4-BE49-F238E27FC236}">
-                <a16:creationId xmlns:a16="http://schemas.microsoft.com/office/drawing/2014/main" id="{AC87F35D-0F1F-49E8-9D0B-CDFCC1C40584}"/>
+                <a16:creationId xmlns:a16="http://schemas.microsoft.com/office/drawing/2014/main" id="{541D8AB2-FA4C-43C7-A521-2E66BB99E2FB}"/>
               </a:ext>
             </a:extLst>
           </p:cNvPr>
@@ -2723,7 +2726,7 @@
     </p:spTree>
     <p:extLst>
       <p:ext uri="{BB962C8B-B14F-4D97-AF65-F5344CB8AC3E}">
-        <p14:creationId xmlns:p14="http://schemas.microsoft.com/office/powerpoint/2010/main" val="1090404138"/>
+        <p14:creationId xmlns:p14="http://schemas.microsoft.com/office/powerpoint/2010/main" val="1696016778"/>
       </p:ext>
     </p:extLst>
   </p:cSld>
@@ -2754,7 +2757,7 @@
           <p:cNvPr id="14" name="eyebrow-2">
             <a:extLst xmlns:a="http://schemas.openxmlformats.org/drawingml/2006/main">
               <a:ext uri="{FF2B5EF4-FFF2-40B4-BE49-F238E27FC236}">
-                <a16:creationId xmlns:a16="http://schemas.microsoft.com/office/drawing/2014/main" id="{2BFBC322-7AF8-4DCD-A3CB-11ADC78B0CA2}"/>
+                <a16:creationId xmlns:a16="http://schemas.microsoft.com/office/drawing/2014/main" id="{D1CD0C76-AF27-4629-834A-23D6A1172EBC}"/>
               </a:ext>
             </a:extLst>
           </p:cNvPr>
@@ -2816,7 +2819,7 @@
           <p:cNvPr id="2" name="page-2">
             <a:extLst xmlns:a="http://schemas.openxmlformats.org/drawingml/2006/main">
               <a:ext uri="{FF2B5EF4-FFF2-40B4-BE49-F238E27FC236}">
-                <a16:creationId xmlns:a16="http://schemas.microsoft.com/office/drawing/2014/main" id="{52A47A68-F390-4EF3-8747-F5872924A339}"/>
+                <a16:creationId xmlns:a16="http://schemas.microsoft.com/office/drawing/2014/main" id="{BB64C5FC-0F34-4510-9B15-04462ACE24BD}"/>
               </a:ext>
             </a:extLst>
           </p:cNvPr>
@@ -2878,7 +2881,7 @@
           <p:cNvPr id="3" name="title-2">
             <a:extLst xmlns:a="http://schemas.openxmlformats.org/drawingml/2006/main">
               <a:ext uri="{FF2B5EF4-FFF2-40B4-BE49-F238E27FC236}">
-                <a16:creationId xmlns:a16="http://schemas.microsoft.com/office/drawing/2014/main" id="{C5A1728D-1E90-4EDB-BFD6-5DBD26BAE408}"/>
+                <a16:creationId xmlns:a16="http://schemas.microsoft.com/office/drawing/2014/main" id="{FAC0F1E8-CB5C-4DD6-B177-13347DC9D1A5}"/>
               </a:ext>
             </a:extLst>
           </p:cNvPr>
@@ -2940,7 +2943,7 @@
           <p:cNvPr id="4" name="title-rule-2">
             <a:extLst xmlns:a="http://schemas.openxmlformats.org/drawingml/2006/main">
               <a:ext uri="{FF2B5EF4-FFF2-40B4-BE49-F238E27FC236}">
-                <a16:creationId xmlns:a16="http://schemas.microsoft.com/office/drawing/2014/main" id="{54F501DA-1EAF-4540-9704-DA25E29BC89D}"/>
+                <a16:creationId xmlns:a16="http://schemas.microsoft.com/office/drawing/2014/main" id="{E695E249-90C2-4A26-BD04-1C6E91CABFAB}"/>
               </a:ext>
             </a:extLst>
           </p:cNvPr>
@@ -2978,7 +2981,7 @@
         </p:xfrm>
         <a:graphic xmlns:a="http://schemas.openxmlformats.org/drawingml/2006/main">
           <a:graphicData uri="http://schemas.openxmlformats.org/drawingml/2006/chart">
-            <c:chart xmlns:r="http://schemas.openxmlformats.org/officeDocument/2006/relationships" xmlns:c="http://schemas.openxmlformats.org/drawingml/2006/chart" r:id="R252525b87f7944d9"/>
+            <c:chart xmlns:r="http://schemas.openxmlformats.org/officeDocument/2006/relationships" xmlns:c="http://schemas.openxmlformats.org/drawingml/2006/chart" r:id="Re94efa8f083247c8"/>
           </a:graphicData>
         </a:graphic>
       </p:graphicFrame>
@@ -2987,7 +2990,7 @@
           <p:cNvPr id="6" name="borrower-callout">
             <a:extLst xmlns:a="http://schemas.openxmlformats.org/drawingml/2006/main">
               <a:ext uri="{FF2B5EF4-FFF2-40B4-BE49-F238E27FC236}">
-                <a16:creationId xmlns:a16="http://schemas.microsoft.com/office/drawing/2014/main" id="{B44B086E-E8FD-4B98-9C53-0F1CDFA35F82}"/>
+                <a16:creationId xmlns:a16="http://schemas.microsoft.com/office/drawing/2014/main" id="{09DB1D91-082A-43AB-AFAF-5F77B576AE39}"/>
               </a:ext>
             </a:extLst>
           </p:cNvPr>
@@ -3018,7 +3021,7 @@
           <p:cNvPr id="7" name="borrower-callout-head">
             <a:extLst xmlns:a="http://schemas.openxmlformats.org/drawingml/2006/main">
               <a:ext uri="{FF2B5EF4-FFF2-40B4-BE49-F238E27FC236}">
-                <a16:creationId xmlns:a16="http://schemas.microsoft.com/office/drawing/2014/main" id="{D7126311-801A-4AB1-8499-E5D86C465D7C}"/>
+                <a16:creationId xmlns:a16="http://schemas.microsoft.com/office/drawing/2014/main" id="{A21152A3-2F83-4236-BF5E-D69748BC854E}"/>
               </a:ext>
             </a:extLst>
           </p:cNvPr>
@@ -3080,7 +3083,7 @@
           <p:cNvPr id="8" name="borrower-next40">
             <a:extLst xmlns:a="http://schemas.openxmlformats.org/drawingml/2006/main">
               <a:ext uri="{FF2B5EF4-FFF2-40B4-BE49-F238E27FC236}">
-                <a16:creationId xmlns:a16="http://schemas.microsoft.com/office/drawing/2014/main" id="{B46D97F1-F6D0-41DF-B3B4-B82F118F5D63}"/>
+                <a16:creationId xmlns:a16="http://schemas.microsoft.com/office/drawing/2014/main" id="{9C114B42-8A74-40AB-AA5F-4227800B33A2}"/>
               </a:ext>
             </a:extLst>
           </p:cNvPr>
@@ -3142,7 +3145,7 @@
           <p:cNvPr id="9" name="borrower-next40-label">
             <a:extLst xmlns:a="http://schemas.openxmlformats.org/drawingml/2006/main">
               <a:ext uri="{FF2B5EF4-FFF2-40B4-BE49-F238E27FC236}">
-                <a16:creationId xmlns:a16="http://schemas.microsoft.com/office/drawing/2014/main" id="{D20FC1F1-3173-4DFB-8CEB-A16A1DB17326}"/>
+                <a16:creationId xmlns:a16="http://schemas.microsoft.com/office/drawing/2014/main" id="{26BF9A5C-07E6-48AB-98BF-77B7D340A53D}"/>
               </a:ext>
             </a:extLst>
           </p:cNvPr>
@@ -3204,7 +3207,7 @@
           <p:cNvPr id="10" name="borrower-contrast">
             <a:extLst xmlns:a="http://schemas.openxmlformats.org/drawingml/2006/main">
               <a:ext uri="{FF2B5EF4-FFF2-40B4-BE49-F238E27FC236}">
-                <a16:creationId xmlns:a16="http://schemas.microsoft.com/office/drawing/2014/main" id="{65539AB7-FC18-426D-BB5A-E340CACF0010}"/>
+                <a16:creationId xmlns:a16="http://schemas.microsoft.com/office/drawing/2014/main" id="{E824FBE0-7D95-4204-9C30-88F61F3BE6F7}"/>
               </a:ext>
             </a:extLst>
           </p:cNvPr>
@@ -3266,7 +3269,7 @@
           <p:cNvPr id="11" name="implication-band-2">
             <a:extLst xmlns:a="http://schemas.openxmlformats.org/drawingml/2006/main">
               <a:ext uri="{FF2B5EF4-FFF2-40B4-BE49-F238E27FC236}">
-                <a16:creationId xmlns:a16="http://schemas.microsoft.com/office/drawing/2014/main" id="{A50FCB66-63B2-4E7E-856B-A219A9EF3D6B}"/>
+                <a16:creationId xmlns:a16="http://schemas.microsoft.com/office/drawing/2014/main" id="{4B383F4D-AAA5-4124-B973-F8ADB5E88C06}"/>
               </a:ext>
             </a:extLst>
           </p:cNvPr>
@@ -3297,7 +3300,7 @@
           <p:cNvPr id="12" name="implication-2">
             <a:extLst xmlns:a="http://schemas.openxmlformats.org/drawingml/2006/main">
               <a:ext uri="{FF2B5EF4-FFF2-40B4-BE49-F238E27FC236}">
-                <a16:creationId xmlns:a16="http://schemas.microsoft.com/office/drawing/2014/main" id="{9AC8CCB1-339F-412C-9D38-8228681F3EFA}"/>
+                <a16:creationId xmlns:a16="http://schemas.microsoft.com/office/drawing/2014/main" id="{BA8B0C6B-41D6-4797-9DC7-B0BDAC1555DF}"/>
               </a:ext>
             </a:extLst>
           </p:cNvPr>
@@ -3359,7 +3362,7 @@
           <p:cNvPr id="13" name="source-2">
             <a:extLst xmlns:a="http://schemas.openxmlformats.org/drawingml/2006/main">
               <a:ext uri="{FF2B5EF4-FFF2-40B4-BE49-F238E27FC236}">
-                <a16:creationId xmlns:a16="http://schemas.microsoft.com/office/drawing/2014/main" id="{1D97F2B6-18F4-4D1A-BD87-AE0F6499124B}"/>
+                <a16:creationId xmlns:a16="http://schemas.microsoft.com/office/drawing/2014/main" id="{3F72D6FD-C0D2-4B9D-A8B1-9E44246D6261}"/>
               </a:ext>
             </a:extLst>
           </p:cNvPr>
@@ -3419,7 +3422,7 @@
     </p:spTree>
     <p:extLst>
       <p:ext uri="{BB962C8B-B14F-4D97-AF65-F5344CB8AC3E}">
-        <p14:creationId xmlns:p14="http://schemas.microsoft.com/office/powerpoint/2010/main" val="2041373152"/>
+        <p14:creationId xmlns:p14="http://schemas.microsoft.com/office/powerpoint/2010/main" val="643993353"/>
       </p:ext>
     </p:extLst>
   </p:cSld>
@@ -3450,7 +3453,7 @@
           <p:cNvPr id="14" name="eyebrow-3">
             <a:extLst xmlns:a="http://schemas.openxmlformats.org/drawingml/2006/main">
               <a:ext uri="{FF2B5EF4-FFF2-40B4-BE49-F238E27FC236}">
-                <a16:creationId xmlns:a16="http://schemas.microsoft.com/office/drawing/2014/main" id="{58CB3A3E-6A93-4C1E-883E-97A8E194E9C7}"/>
+                <a16:creationId xmlns:a16="http://schemas.microsoft.com/office/drawing/2014/main" id="{93261DA2-C780-44EA-91E5-122655EC6E77}"/>
               </a:ext>
             </a:extLst>
           </p:cNvPr>
@@ -3512,7 +3515,7 @@
           <p:cNvPr id="2" name="page-3">
             <a:extLst xmlns:a="http://schemas.openxmlformats.org/drawingml/2006/main">
               <a:ext uri="{FF2B5EF4-FFF2-40B4-BE49-F238E27FC236}">
-                <a16:creationId xmlns:a16="http://schemas.microsoft.com/office/drawing/2014/main" id="{1E9D3AB4-0FAE-4C7B-ACBE-ECAFD470A718}"/>
+                <a16:creationId xmlns:a16="http://schemas.microsoft.com/office/drawing/2014/main" id="{91FD943B-4ABB-42C2-A98A-A10AFC5A2F69}"/>
               </a:ext>
             </a:extLst>
           </p:cNvPr>
@@ -3574,7 +3577,7 @@
           <p:cNvPr id="3" name="title-3">
             <a:extLst xmlns:a="http://schemas.openxmlformats.org/drawingml/2006/main">
               <a:ext uri="{FF2B5EF4-FFF2-40B4-BE49-F238E27FC236}">
-                <a16:creationId xmlns:a16="http://schemas.microsoft.com/office/drawing/2014/main" id="{B44FFF79-4C96-44BF-BD41-81DDE3C39172}"/>
+                <a16:creationId xmlns:a16="http://schemas.microsoft.com/office/drawing/2014/main" id="{ABF02254-494E-4C5F-AFD7-AB595F82E6CF}"/>
               </a:ext>
             </a:extLst>
           </p:cNvPr>
@@ -3636,7 +3639,7 @@
           <p:cNvPr id="4" name="title-rule-3">
             <a:extLst xmlns:a="http://schemas.openxmlformats.org/drawingml/2006/main">
               <a:ext uri="{FF2B5EF4-FFF2-40B4-BE49-F238E27FC236}">
-                <a16:creationId xmlns:a16="http://schemas.microsoft.com/office/drawing/2014/main" id="{2BF0F4E3-FADD-424D-B110-BA01143D6375}"/>
+                <a16:creationId xmlns:a16="http://schemas.microsoft.com/office/drawing/2014/main" id="{152424A1-4299-46AD-BCA0-6FC434EDAFBA}"/>
               </a:ext>
             </a:extLst>
           </p:cNvPr>
@@ -3674,7 +3677,7 @@
         </p:xfrm>
         <a:graphic xmlns:a="http://schemas.openxmlformats.org/drawingml/2006/main">
           <a:graphicData uri="http://schemas.openxmlformats.org/drawingml/2006/chart">
-            <c:chart xmlns:r="http://schemas.openxmlformats.org/officeDocument/2006/relationships" xmlns:c="http://schemas.openxmlformats.org/drawingml/2006/chart" r:id="R128f2bc0fd9c4517"/>
+            <c:chart xmlns:r="http://schemas.openxmlformats.org/officeDocument/2006/relationships" xmlns:c="http://schemas.openxmlformats.org/drawingml/2006/chart" r:id="Ra69fe7b1057c41de"/>
           </a:graphicData>
         </a:graphic>
       </p:graphicFrame>
@@ -3683,7 +3686,7 @@
           <p:cNvPr id="6" name="saving-callout">
             <a:extLst xmlns:a="http://schemas.openxmlformats.org/drawingml/2006/main">
               <a:ext uri="{FF2B5EF4-FFF2-40B4-BE49-F238E27FC236}">
-                <a16:creationId xmlns:a16="http://schemas.microsoft.com/office/drawing/2014/main" id="{3592225C-77F8-43C9-A780-B86E1142D3FC}"/>
+                <a16:creationId xmlns:a16="http://schemas.microsoft.com/office/drawing/2014/main" id="{6E8B3ACF-AABF-4235-8354-2927E213A960}"/>
               </a:ext>
             </a:extLst>
           </p:cNvPr>
@@ -3714,7 +3717,7 @@
           <p:cNvPr id="7" name="saving-callout-head">
             <a:extLst xmlns:a="http://schemas.openxmlformats.org/drawingml/2006/main">
               <a:ext uri="{FF2B5EF4-FFF2-40B4-BE49-F238E27FC236}">
-                <a16:creationId xmlns:a16="http://schemas.microsoft.com/office/drawing/2014/main" id="{F86BB777-D910-4728-84F0-BD31451355B4}"/>
+                <a16:creationId xmlns:a16="http://schemas.microsoft.com/office/drawing/2014/main" id="{A0784F4E-D0E2-48BD-BADC-E9178D28700D}"/>
               </a:ext>
             </a:extLst>
           </p:cNvPr>
@@ -3776,7 +3779,7 @@
           <p:cNvPr id="8" name="saving-next40">
             <a:extLst xmlns:a="http://schemas.openxmlformats.org/drawingml/2006/main">
               <a:ext uri="{FF2B5EF4-FFF2-40B4-BE49-F238E27FC236}">
-                <a16:creationId xmlns:a16="http://schemas.microsoft.com/office/drawing/2014/main" id="{414281AC-0CB0-4A1B-A140-1F2D8F407C52}"/>
+                <a16:creationId xmlns:a16="http://schemas.microsoft.com/office/drawing/2014/main" id="{6CD98478-3B62-40E3-AC3C-35407701A38E}"/>
               </a:ext>
             </a:extLst>
           </p:cNvPr>
@@ -3838,7 +3841,7 @@
           <p:cNvPr id="9" name="saving-next40-label">
             <a:extLst xmlns:a="http://schemas.openxmlformats.org/drawingml/2006/main">
               <a:ext uri="{FF2B5EF4-FFF2-40B4-BE49-F238E27FC236}">
-                <a16:creationId xmlns:a16="http://schemas.microsoft.com/office/drawing/2014/main" id="{BC0A0CF3-09AA-4182-9E93-97B356D004F8}"/>
+                <a16:creationId xmlns:a16="http://schemas.microsoft.com/office/drawing/2014/main" id="{C16EDC9F-0615-48D9-9DB8-A6003845B9A3}"/>
               </a:ext>
             </a:extLst>
           </p:cNvPr>
@@ -3900,7 +3903,7 @@
           <p:cNvPr id="10" name="saving-contrast">
             <a:extLst xmlns:a="http://schemas.openxmlformats.org/drawingml/2006/main">
               <a:ext uri="{FF2B5EF4-FFF2-40B4-BE49-F238E27FC236}">
-                <a16:creationId xmlns:a16="http://schemas.microsoft.com/office/drawing/2014/main" id="{7E6096EA-2A74-4350-B145-6E4A78C4C8C8}"/>
+                <a16:creationId xmlns:a16="http://schemas.microsoft.com/office/drawing/2014/main" id="{D4145115-C1C9-4BEC-A5D0-FF0DD22675A5}"/>
               </a:ext>
             </a:extLst>
           </p:cNvPr>
@@ -3962,7 +3965,7 @@
           <p:cNvPr id="11" name="implication-band-3">
             <a:extLst xmlns:a="http://schemas.openxmlformats.org/drawingml/2006/main">
               <a:ext uri="{FF2B5EF4-FFF2-40B4-BE49-F238E27FC236}">
-                <a16:creationId xmlns:a16="http://schemas.microsoft.com/office/drawing/2014/main" id="{F8174ED4-41D2-4E8E-BA56-85CB56666915}"/>
+                <a16:creationId xmlns:a16="http://schemas.microsoft.com/office/drawing/2014/main" id="{D5B0EA41-A326-4223-A9F1-6B6D783789A9}"/>
               </a:ext>
             </a:extLst>
           </p:cNvPr>
@@ -3993,7 +3996,7 @@
           <p:cNvPr id="12" name="implication-3">
             <a:extLst xmlns:a="http://schemas.openxmlformats.org/drawingml/2006/main">
               <a:ext uri="{FF2B5EF4-FFF2-40B4-BE49-F238E27FC236}">
-                <a16:creationId xmlns:a16="http://schemas.microsoft.com/office/drawing/2014/main" id="{BADE951D-E52C-4405-B43B-7EA27DA8A2D9}"/>
+                <a16:creationId xmlns:a16="http://schemas.microsoft.com/office/drawing/2014/main" id="{80F3846D-AFE5-491B-BB53-79AD287635BA}"/>
               </a:ext>
             </a:extLst>
           </p:cNvPr>
@@ -4055,7 +4058,7 @@
           <p:cNvPr id="13" name="source-3">
             <a:extLst xmlns:a="http://schemas.openxmlformats.org/drawingml/2006/main">
               <a:ext uri="{FF2B5EF4-FFF2-40B4-BE49-F238E27FC236}">
-                <a16:creationId xmlns:a16="http://schemas.microsoft.com/office/drawing/2014/main" id="{D05F340C-E55A-4363-9512-F990B8E56A9A}"/>
+                <a16:creationId xmlns:a16="http://schemas.microsoft.com/office/drawing/2014/main" id="{6AD9837E-07DE-4808-80FF-F7AA3D3C0DF0}"/>
               </a:ext>
             </a:extLst>
           </p:cNvPr>
@@ -4115,7 +4118,7 @@
     </p:spTree>
     <p:extLst>
       <p:ext uri="{BB962C8B-B14F-4D97-AF65-F5344CB8AC3E}">
-        <p14:creationId xmlns:p14="http://schemas.microsoft.com/office/powerpoint/2010/main" val="1819558228"/>
+        <p14:creationId xmlns:p14="http://schemas.microsoft.com/office/powerpoint/2010/main" val="1210123477"/>
       </p:ext>
     </p:extLst>
   </p:cSld>
@@ -4146,7 +4149,7 @@
           <p:cNvPr id="15" name="eyebrow-4">
             <a:extLst xmlns:a="http://schemas.openxmlformats.org/drawingml/2006/main">
               <a:ext uri="{FF2B5EF4-FFF2-40B4-BE49-F238E27FC236}">
-                <a16:creationId xmlns:a16="http://schemas.microsoft.com/office/drawing/2014/main" id="{082846A9-8465-433A-BF9D-83A132C170F2}"/>
+                <a16:creationId xmlns:a16="http://schemas.microsoft.com/office/drawing/2014/main" id="{04D27481-2D51-4FDC-A458-E50B46BAA204}"/>
               </a:ext>
             </a:extLst>
           </p:cNvPr>
@@ -4208,7 +4211,7 @@
           <p:cNvPr id="2" name="page-4">
             <a:extLst xmlns:a="http://schemas.openxmlformats.org/drawingml/2006/main">
               <a:ext uri="{FF2B5EF4-FFF2-40B4-BE49-F238E27FC236}">
-                <a16:creationId xmlns:a16="http://schemas.microsoft.com/office/drawing/2014/main" id="{F2234565-615B-4BB0-94E4-8E168EE1C02C}"/>
+                <a16:creationId xmlns:a16="http://schemas.microsoft.com/office/drawing/2014/main" id="{3FBCA310-3DE7-4459-A68A-7A7321114CCC}"/>
               </a:ext>
             </a:extLst>
           </p:cNvPr>
@@ -4270,7 +4273,7 @@
           <p:cNvPr id="3" name="title-4">
             <a:extLst xmlns:a="http://schemas.openxmlformats.org/drawingml/2006/main">
               <a:ext uri="{FF2B5EF4-FFF2-40B4-BE49-F238E27FC236}">
-                <a16:creationId xmlns:a16="http://schemas.microsoft.com/office/drawing/2014/main" id="{7C3EB8DD-59E9-44B4-90F9-397580885ABC}"/>
+                <a16:creationId xmlns:a16="http://schemas.microsoft.com/office/drawing/2014/main" id="{13C7AD41-C051-4BE1-B3DF-9419811B0666}"/>
               </a:ext>
             </a:extLst>
           </p:cNvPr>
@@ -4332,7 +4335,7 @@
           <p:cNvPr id="4" name="title-rule-4">
             <a:extLst xmlns:a="http://schemas.openxmlformats.org/drawingml/2006/main">
               <a:ext uri="{FF2B5EF4-FFF2-40B4-BE49-F238E27FC236}">
-                <a16:creationId xmlns:a16="http://schemas.microsoft.com/office/drawing/2014/main" id="{4EDF3FAC-EFC3-4D7F-8101-FED27FF206B5}"/>
+                <a16:creationId xmlns:a16="http://schemas.microsoft.com/office/drawing/2014/main" id="{B937DE71-60F9-4EA0-8DBE-8BD108413904}"/>
               </a:ext>
             </a:extLst>
           </p:cNvPr>
@@ -4370,7 +4373,7 @@
         </p:xfrm>
         <a:graphic xmlns:a="http://schemas.openxmlformats.org/drawingml/2006/main">
           <a:graphicData uri="http://schemas.openxmlformats.org/drawingml/2006/chart">
-            <c:chart xmlns:r="http://schemas.openxmlformats.org/officeDocument/2006/relationships" xmlns:c="http://schemas.openxmlformats.org/drawingml/2006/chart" r:id="R20f057f345414fd3"/>
+            <c:chart xmlns:r="http://schemas.openxmlformats.org/officeDocument/2006/relationships" xmlns:c="http://schemas.openxmlformats.org/drawingml/2006/chart" r:id="R910c68f349d24a65"/>
           </a:graphicData>
         </a:graphic>
       </p:graphicFrame>
@@ -4379,7 +4382,7 @@
           <p:cNvPr id="6" name="unveiling-callout">
             <a:extLst xmlns:a="http://schemas.openxmlformats.org/drawingml/2006/main">
               <a:ext uri="{FF2B5EF4-FFF2-40B4-BE49-F238E27FC236}">
-                <a16:creationId xmlns:a16="http://schemas.microsoft.com/office/drawing/2014/main" id="{47BCF1F6-7BFE-4E24-8786-60E06BC23C78}"/>
+                <a16:creationId xmlns:a16="http://schemas.microsoft.com/office/drawing/2014/main" id="{46BEFB9F-3CE7-4B0F-B11B-8442C71F68B6}"/>
               </a:ext>
             </a:extLst>
           </p:cNvPr>
@@ -4410,7 +4413,7 @@
           <p:cNvPr id="7" name="unveiling-callout-head">
             <a:extLst xmlns:a="http://schemas.openxmlformats.org/drawingml/2006/main">
               <a:ext uri="{FF2B5EF4-FFF2-40B4-BE49-F238E27FC236}">
-                <a16:creationId xmlns:a16="http://schemas.microsoft.com/office/drawing/2014/main" id="{B1AC4BFB-EFB5-4AC9-AFC4-8683FD7E0365}"/>
+                <a16:creationId xmlns:a16="http://schemas.microsoft.com/office/drawing/2014/main" id="{F66C261D-099D-4A04-A8D3-9BB759A6F493}"/>
               </a:ext>
             </a:extLst>
           </p:cNvPr>
@@ -4472,7 +4475,7 @@
           <p:cNvPr id="8" name="unveiling-top1">
             <a:extLst xmlns:a="http://schemas.openxmlformats.org/drawingml/2006/main">
               <a:ext uri="{FF2B5EF4-FFF2-40B4-BE49-F238E27FC236}">
-                <a16:creationId xmlns:a16="http://schemas.microsoft.com/office/drawing/2014/main" id="{1E49303A-E8B3-4196-90AA-74429272B5B0}"/>
+                <a16:creationId xmlns:a16="http://schemas.microsoft.com/office/drawing/2014/main" id="{1E2D59D0-34FC-4666-9356-6AC891D98394}"/>
               </a:ext>
             </a:extLst>
           </p:cNvPr>
@@ -4534,7 +4537,7 @@
           <p:cNvPr id="9" name="unveiling-top1-label">
             <a:extLst xmlns:a="http://schemas.openxmlformats.org/drawingml/2006/main">
               <a:ext uri="{FF2B5EF4-FFF2-40B4-BE49-F238E27FC236}">
-                <a16:creationId xmlns:a16="http://schemas.microsoft.com/office/drawing/2014/main" id="{97F8516E-6D74-4F0A-96A7-694C3553D995}"/>
+                <a16:creationId xmlns:a16="http://schemas.microsoft.com/office/drawing/2014/main" id="{6E6C2350-D9B3-4A9E-AD6E-63D6413706CD}"/>
               </a:ext>
             </a:extLst>
           </p:cNvPr>
@@ -4596,7 +4599,7 @@
           <p:cNvPr id="10" name="unveiling-next40">
             <a:extLst xmlns:a="http://schemas.openxmlformats.org/drawingml/2006/main">
               <a:ext uri="{FF2B5EF4-FFF2-40B4-BE49-F238E27FC236}">
-                <a16:creationId xmlns:a16="http://schemas.microsoft.com/office/drawing/2014/main" id="{365CEB72-6399-4174-B870-6EFD48147287}"/>
+                <a16:creationId xmlns:a16="http://schemas.microsoft.com/office/drawing/2014/main" id="{A59386EE-960A-49E3-B63F-D6D6A0076EBC}"/>
               </a:ext>
             </a:extLst>
           </p:cNvPr>
@@ -4658,7 +4661,7 @@
           <p:cNvPr id="11" name="unveiling-next40-label">
             <a:extLst xmlns:a="http://schemas.openxmlformats.org/drawingml/2006/main">
               <a:ext uri="{FF2B5EF4-FFF2-40B4-BE49-F238E27FC236}">
-                <a16:creationId xmlns:a16="http://schemas.microsoft.com/office/drawing/2014/main" id="{FFB75C12-0DCE-4775-A25A-A2F7FC2E01B2}"/>
+                <a16:creationId xmlns:a16="http://schemas.microsoft.com/office/drawing/2014/main" id="{F774C9D0-7893-4A1F-A5E2-A5D98AF74A9F}"/>
               </a:ext>
             </a:extLst>
           </p:cNvPr>
@@ -4720,7 +4723,7 @@
           <p:cNvPr id="12" name="implication-band-4">
             <a:extLst xmlns:a="http://schemas.openxmlformats.org/drawingml/2006/main">
               <a:ext uri="{FF2B5EF4-FFF2-40B4-BE49-F238E27FC236}">
-                <a16:creationId xmlns:a16="http://schemas.microsoft.com/office/drawing/2014/main" id="{FBC1B51D-743B-4869-8D28-4A0A31AFBFEE}"/>
+                <a16:creationId xmlns:a16="http://schemas.microsoft.com/office/drawing/2014/main" id="{F99C7C96-A626-4ED9-AA36-1DFFFFE09157}"/>
               </a:ext>
             </a:extLst>
           </p:cNvPr>
@@ -4751,7 +4754,7 @@
           <p:cNvPr id="13" name="implication-4">
             <a:extLst xmlns:a="http://schemas.openxmlformats.org/drawingml/2006/main">
               <a:ext uri="{FF2B5EF4-FFF2-40B4-BE49-F238E27FC236}">
-                <a16:creationId xmlns:a16="http://schemas.microsoft.com/office/drawing/2014/main" id="{FAF8B18F-54A4-4BE1-87A3-0DC7091A26F5}"/>
+                <a16:creationId xmlns:a16="http://schemas.microsoft.com/office/drawing/2014/main" id="{7927E323-74AF-4077-B4ED-E330091CEBD3}"/>
               </a:ext>
             </a:extLst>
           </p:cNvPr>
@@ -4813,7 +4816,7 @@
           <p:cNvPr id="14" name="source-4">
             <a:extLst xmlns:a="http://schemas.openxmlformats.org/drawingml/2006/main">
               <a:ext uri="{FF2B5EF4-FFF2-40B4-BE49-F238E27FC236}">
-                <a16:creationId xmlns:a16="http://schemas.microsoft.com/office/drawing/2014/main" id="{EE899237-8208-4781-9C0D-46A969CFF9B4}"/>
+                <a16:creationId xmlns:a16="http://schemas.microsoft.com/office/drawing/2014/main" id="{537BBD31-6288-48F6-9A86-03C97EDBCA95}"/>
               </a:ext>
             </a:extLst>
           </p:cNvPr>
@@ -4873,7 +4876,7 @@
     </p:spTree>
     <p:extLst>
       <p:ext uri="{BB962C8B-B14F-4D97-AF65-F5344CB8AC3E}">
-        <p14:creationId xmlns:p14="http://schemas.microsoft.com/office/powerpoint/2010/main" val="907223475"/>
+        <p14:creationId xmlns:p14="http://schemas.microsoft.com/office/powerpoint/2010/main" val="667014454"/>
       </p:ext>
     </p:extLst>
   </p:cSld>
@@ -4904,7 +4907,7 @@
           <p:cNvPr id="19" name="eyebrow-5">
             <a:extLst xmlns:a="http://schemas.openxmlformats.org/drawingml/2006/main">
               <a:ext uri="{FF2B5EF4-FFF2-40B4-BE49-F238E27FC236}">
-                <a16:creationId xmlns:a16="http://schemas.microsoft.com/office/drawing/2014/main" id="{DDC34EFA-C70F-4121-9780-BA601F5DCA2C}"/>
+                <a16:creationId xmlns:a16="http://schemas.microsoft.com/office/drawing/2014/main" id="{B7E82457-90C6-4314-BA41-630C35AF3260}"/>
               </a:ext>
             </a:extLst>
           </p:cNvPr>
@@ -4966,7 +4969,7 @@
           <p:cNvPr id="2" name="page-5">
             <a:extLst xmlns:a="http://schemas.openxmlformats.org/drawingml/2006/main">
               <a:ext uri="{FF2B5EF4-FFF2-40B4-BE49-F238E27FC236}">
-                <a16:creationId xmlns:a16="http://schemas.microsoft.com/office/drawing/2014/main" id="{C9632ED7-9FBA-4A5B-AB98-A9A4C422BD49}"/>
+                <a16:creationId xmlns:a16="http://schemas.microsoft.com/office/drawing/2014/main" id="{632A8695-AB68-4847-9051-1E65BC22DF54}"/>
               </a:ext>
             </a:extLst>
           </p:cNvPr>
@@ -5028,7 +5031,7 @@
           <p:cNvPr id="3" name="title-5">
             <a:extLst xmlns:a="http://schemas.openxmlformats.org/drawingml/2006/main">
               <a:ext uri="{FF2B5EF4-FFF2-40B4-BE49-F238E27FC236}">
-                <a16:creationId xmlns:a16="http://schemas.microsoft.com/office/drawing/2014/main" id="{B1B1523B-277E-471A-AD61-2D404472AFF1}"/>
+                <a16:creationId xmlns:a16="http://schemas.microsoft.com/office/drawing/2014/main" id="{F73F20B1-6BB7-4DE3-8A9E-914540C39372}"/>
               </a:ext>
             </a:extLst>
           </p:cNvPr>
@@ -5090,7 +5093,7 @@
           <p:cNvPr id="4" name="title-rule-5">
             <a:extLst xmlns:a="http://schemas.openxmlformats.org/drawingml/2006/main">
               <a:ext uri="{FF2B5EF4-FFF2-40B4-BE49-F238E27FC236}">
-                <a16:creationId xmlns:a16="http://schemas.microsoft.com/office/drawing/2014/main" id="{CB60D68D-4796-45C9-A03E-60C1238EE8C1}"/>
+                <a16:creationId xmlns:a16="http://schemas.microsoft.com/office/drawing/2014/main" id="{09313067-A78D-4785-8D98-6614C86484A1}"/>
               </a:ext>
             </a:extLst>
           </p:cNvPr>
@@ -5121,7 +5124,7 @@
           <p:cNvPr id="5" name="step-1-number">
             <a:extLst xmlns:a="http://schemas.openxmlformats.org/drawingml/2006/main">
               <a:ext uri="{FF2B5EF4-FFF2-40B4-BE49-F238E27FC236}">
-                <a16:creationId xmlns:a16="http://schemas.microsoft.com/office/drawing/2014/main" id="{D69633A3-5F24-4368-9654-8E077DBC65B3}"/>
+                <a16:creationId xmlns:a16="http://schemas.microsoft.com/office/drawing/2014/main" id="{8FB10CAA-71A6-49C4-BFB9-CA29FD46C0DD}"/>
               </a:ext>
             </a:extLst>
           </p:cNvPr>
@@ -5183,7 +5186,7 @@
           <p:cNvPr id="6" name="step-1-head">
             <a:extLst xmlns:a="http://schemas.openxmlformats.org/drawingml/2006/main">
               <a:ext uri="{FF2B5EF4-FFF2-40B4-BE49-F238E27FC236}">
-                <a16:creationId xmlns:a16="http://schemas.microsoft.com/office/drawing/2014/main" id="{D6DFF213-09A6-4F03-909E-39CD583660C1}"/>
+                <a16:creationId xmlns:a16="http://schemas.microsoft.com/office/drawing/2014/main" id="{EF971A34-727D-4B2C-8746-C499C6414CE3}"/>
               </a:ext>
             </a:extLst>
           </p:cNvPr>
@@ -5245,7 +5248,7 @@
           <p:cNvPr id="7" name="step-1-body">
             <a:extLst xmlns:a="http://schemas.openxmlformats.org/drawingml/2006/main">
               <a:ext uri="{FF2B5EF4-FFF2-40B4-BE49-F238E27FC236}">
-                <a16:creationId xmlns:a16="http://schemas.microsoft.com/office/drawing/2014/main" id="{FE82270F-BDC3-424C-9EF3-B9F57492186F}"/>
+                <a16:creationId xmlns:a16="http://schemas.microsoft.com/office/drawing/2014/main" id="{FA8DF4DE-7A69-4B5C-9D9B-FCAD37DF67F1}"/>
               </a:ext>
             </a:extLst>
           </p:cNvPr>
@@ -5307,7 +5310,7 @@
           <p:cNvPr id="8" name="step-divider-1">
             <a:extLst xmlns:a="http://schemas.openxmlformats.org/drawingml/2006/main">
               <a:ext uri="{FF2B5EF4-FFF2-40B4-BE49-F238E27FC236}">
-                <a16:creationId xmlns:a16="http://schemas.microsoft.com/office/drawing/2014/main" id="{F312048D-E3EA-4B87-9296-4518A46393DE}"/>
+                <a16:creationId xmlns:a16="http://schemas.microsoft.com/office/drawing/2014/main" id="{3BC8E3FF-32CD-48DC-94A5-E765EE8BF864}"/>
               </a:ext>
             </a:extLst>
           </p:cNvPr>
@@ -5338,7 +5341,7 @@
           <p:cNvPr id="9" name="step-2-number">
             <a:extLst xmlns:a="http://schemas.openxmlformats.org/drawingml/2006/main">
               <a:ext uri="{FF2B5EF4-FFF2-40B4-BE49-F238E27FC236}">
-                <a16:creationId xmlns:a16="http://schemas.microsoft.com/office/drawing/2014/main" id="{44F2638C-CDA8-44CF-A088-459BEE379703}"/>
+                <a16:creationId xmlns:a16="http://schemas.microsoft.com/office/drawing/2014/main" id="{FFF652BA-D86E-4D6B-969A-B95AC6258192}"/>
               </a:ext>
             </a:extLst>
           </p:cNvPr>
@@ -5400,7 +5403,7 @@
           <p:cNvPr id="10" name="step-2-head">
             <a:extLst xmlns:a="http://schemas.openxmlformats.org/drawingml/2006/main">
               <a:ext uri="{FF2B5EF4-FFF2-40B4-BE49-F238E27FC236}">
-                <a16:creationId xmlns:a16="http://schemas.microsoft.com/office/drawing/2014/main" id="{CFB33606-E822-408D-BB34-88BE9BC81C8B}"/>
+                <a16:creationId xmlns:a16="http://schemas.microsoft.com/office/drawing/2014/main" id="{EBB7E9BE-54D0-4E6F-9EE0-39C203882A2D}"/>
               </a:ext>
             </a:extLst>
           </p:cNvPr>
@@ -5462,7 +5465,7 @@
           <p:cNvPr id="11" name="step-2-body">
             <a:extLst xmlns:a="http://schemas.openxmlformats.org/drawingml/2006/main">
               <a:ext uri="{FF2B5EF4-FFF2-40B4-BE49-F238E27FC236}">
-                <a16:creationId xmlns:a16="http://schemas.microsoft.com/office/drawing/2014/main" id="{5A77C8DA-01D0-428C-B1F8-622A8AB8E94B}"/>
+                <a16:creationId xmlns:a16="http://schemas.microsoft.com/office/drawing/2014/main" id="{997759A6-9FCF-439B-B2EA-28BBC7F3E73F}"/>
               </a:ext>
             </a:extLst>
           </p:cNvPr>
@@ -5524,7 +5527,7 @@
           <p:cNvPr id="12" name="step-divider-2">
             <a:extLst xmlns:a="http://schemas.openxmlformats.org/drawingml/2006/main">
               <a:ext uri="{FF2B5EF4-FFF2-40B4-BE49-F238E27FC236}">
-                <a16:creationId xmlns:a16="http://schemas.microsoft.com/office/drawing/2014/main" id="{7FAC27AB-6B9C-42EA-B5A3-5FBD0614D176}"/>
+                <a16:creationId xmlns:a16="http://schemas.microsoft.com/office/drawing/2014/main" id="{CA301640-F5D5-4878-B686-7158D469E89A}"/>
               </a:ext>
             </a:extLst>
           </p:cNvPr>
@@ -5555,7 +5558,7 @@
           <p:cNvPr id="13" name="step-3-number">
             <a:extLst xmlns:a="http://schemas.openxmlformats.org/drawingml/2006/main">
               <a:ext uri="{FF2B5EF4-FFF2-40B4-BE49-F238E27FC236}">
-                <a16:creationId xmlns:a16="http://schemas.microsoft.com/office/drawing/2014/main" id="{AEFCAD10-131A-4B64-AB6C-E00479BF486D}"/>
+                <a16:creationId xmlns:a16="http://schemas.microsoft.com/office/drawing/2014/main" id="{9C44DBC7-6085-4717-880B-33BDBCE172C9}"/>
               </a:ext>
             </a:extLst>
           </p:cNvPr>
@@ -5617,7 +5620,7 @@
           <p:cNvPr id="14" name="step-3-head">
             <a:extLst xmlns:a="http://schemas.openxmlformats.org/drawingml/2006/main">
               <a:ext uri="{FF2B5EF4-FFF2-40B4-BE49-F238E27FC236}">
-                <a16:creationId xmlns:a16="http://schemas.microsoft.com/office/drawing/2014/main" id="{13A82533-DB0A-4DCE-A9BA-25EB2E1C9D53}"/>
+                <a16:creationId xmlns:a16="http://schemas.microsoft.com/office/drawing/2014/main" id="{29F8083F-6092-47F2-B3A2-C81CE37B903A}"/>
               </a:ext>
             </a:extLst>
           </p:cNvPr>
@@ -5679,7 +5682,7 @@
           <p:cNvPr id="15" name="step-3-body">
             <a:extLst xmlns:a="http://schemas.openxmlformats.org/drawingml/2006/main">
               <a:ext uri="{FF2B5EF4-FFF2-40B4-BE49-F238E27FC236}">
-                <a16:creationId xmlns:a16="http://schemas.microsoft.com/office/drawing/2014/main" id="{D011B8A8-7E21-40C3-9708-AC84B3488154}"/>
+                <a16:creationId xmlns:a16="http://schemas.microsoft.com/office/drawing/2014/main" id="{99DD7F76-F1FE-46B2-A561-066DE5B7FD3C}"/>
               </a:ext>
             </a:extLst>
           </p:cNvPr>
@@ -5741,7 +5744,7 @@
           <p:cNvPr id="16" name="implication-band-5">
             <a:extLst xmlns:a="http://schemas.openxmlformats.org/drawingml/2006/main">
               <a:ext uri="{FF2B5EF4-FFF2-40B4-BE49-F238E27FC236}">
-                <a16:creationId xmlns:a16="http://schemas.microsoft.com/office/drawing/2014/main" id="{4C91719A-9575-4F9C-9F21-A5CF8C692FD0}"/>
+                <a16:creationId xmlns:a16="http://schemas.microsoft.com/office/drawing/2014/main" id="{FF43F8FC-059A-45E2-A79E-8C68E525F9F9}"/>
               </a:ext>
             </a:extLst>
           </p:cNvPr>
@@ -5772,7 +5775,7 @@
           <p:cNvPr id="17" name="implication-5">
             <a:extLst xmlns:a="http://schemas.openxmlformats.org/drawingml/2006/main">
               <a:ext uri="{FF2B5EF4-FFF2-40B4-BE49-F238E27FC236}">
-                <a16:creationId xmlns:a16="http://schemas.microsoft.com/office/drawing/2014/main" id="{35C94013-B5DB-4E92-9ED8-C4FD3CBAE27D}"/>
+                <a16:creationId xmlns:a16="http://schemas.microsoft.com/office/drawing/2014/main" id="{1A84FA6F-F6A6-46C1-9FE7-2943F4F63459}"/>
               </a:ext>
             </a:extLst>
           </p:cNvPr>
@@ -5834,7 +5837,7 @@
           <p:cNvPr id="18" name="source-5">
             <a:extLst xmlns:a="http://schemas.openxmlformats.org/drawingml/2006/main">
               <a:ext uri="{FF2B5EF4-FFF2-40B4-BE49-F238E27FC236}">
-                <a16:creationId xmlns:a16="http://schemas.microsoft.com/office/drawing/2014/main" id="{D1A9A269-E4B5-432E-863C-081A78E4B1AB}"/>
+                <a16:creationId xmlns:a16="http://schemas.microsoft.com/office/drawing/2014/main" id="{C2617E52-9F6B-4B0B-AC65-8EF069A2F19F}"/>
               </a:ext>
             </a:extLst>
           </p:cNvPr>
@@ -5894,7 +5897,7 @@
     </p:spTree>
     <p:extLst>
       <p:ext uri="{BB962C8B-B14F-4D97-AF65-F5344CB8AC3E}">
-        <p14:creationId xmlns:p14="http://schemas.microsoft.com/office/powerpoint/2010/main" val="1058960275"/>
+        <p14:creationId xmlns:p14="http://schemas.microsoft.com/office/powerpoint/2010/main" val="88619919"/>
       </p:ext>
     </p:extLst>
   </p:cSld>

</xml_diff>

<commit_message>
Refresh comparison + extension presentation decks
- add direct Figure 6 and Figure 8 comparisons
- move wealth and heatmap diagnostics to the extension deck
- update presentation sources, QA contracts, and project records
</commit_message>
<xml_diff>
--- a/Presentation/7_debt_composition_extension/presentation.pptx
+++ b/Presentation/7_debt_composition_extension/presentation.pptx
@@ -2,17 +2,19 @@
 <file path=ppt/presentation.xml><?xml version="1.0" encoding="utf-8"?>
 <p:presentation xmlns:p="http://schemas.openxmlformats.org/presentationml/2006/main">
   <p:sldMasterIdLst>
-    <p:sldMasterId xmlns:r="http://schemas.openxmlformats.org/officeDocument/2006/relationships" id="2147483648" r:id="R622cea4c6e9b41c9"/>
+    <p:sldMasterId xmlns:r="http://schemas.openxmlformats.org/officeDocument/2006/relationships" id="2147483648" r:id="Rf21024fa5d1941e9"/>
   </p:sldMasterIdLst>
   <p:notesMasterIdLst>
-    <p:notesMasterId xmlns:r="http://schemas.openxmlformats.org/officeDocument/2006/relationships" r:id="R10a34859d6254419"/>
+    <p:notesMasterId xmlns:r="http://schemas.openxmlformats.org/officeDocument/2006/relationships" r:id="Rfc00da5c722142ef"/>
   </p:notesMasterIdLst>
   <p:sldIdLst>
-    <p:sldId xmlns:r="http://schemas.openxmlformats.org/officeDocument/2006/relationships" id="256" r:id="Re8e568bcc2004216"/>
-    <p:sldId xmlns:r="http://schemas.openxmlformats.org/officeDocument/2006/relationships" id="257" r:id="R378bb6fd3b2c4aa7"/>
-    <p:sldId xmlns:r="http://schemas.openxmlformats.org/officeDocument/2006/relationships" id="258" r:id="Rf75c6a25875743fd"/>
-    <p:sldId xmlns:r="http://schemas.openxmlformats.org/officeDocument/2006/relationships" id="259" r:id="R0afb2c5e14a148ab"/>
-    <p:sldId xmlns:r="http://schemas.openxmlformats.org/officeDocument/2006/relationships" id="260" r:id="R8ff50f36e26240bc"/>
+    <p:sldId xmlns:r="http://schemas.openxmlformats.org/officeDocument/2006/relationships" id="256" r:id="Rd50900ad887649c5"/>
+    <p:sldId xmlns:r="http://schemas.openxmlformats.org/officeDocument/2006/relationships" id="257" r:id="R469df545a9e14934"/>
+    <p:sldId xmlns:r="http://schemas.openxmlformats.org/officeDocument/2006/relationships" id="258" r:id="Ra7f14f400d944574"/>
+    <p:sldId xmlns:r="http://schemas.openxmlformats.org/officeDocument/2006/relationships" id="259" r:id="R6d81f65117bd43ea"/>
+    <p:sldId xmlns:r="http://schemas.openxmlformats.org/officeDocument/2006/relationships" id="260" r:id="R0e3d9a619b7942d9"/>
+    <p:sldId xmlns:r="http://schemas.openxmlformats.org/officeDocument/2006/relationships" id="261" r:id="Rc2f1280bb22e4274"/>
+    <p:sldId xmlns:r="http://schemas.openxmlformats.org/officeDocument/2006/relationships" id="262" r:id="R469a268a1f3a49a6"/>
   </p:sldIdLst>
   <p:sldSz cx="12192000" cy="6858000"/>
   <p:notesSz cx="6858000" cy="9144000"/>
@@ -826,6 +828,196 @@
           </a:p>
           <a:p xmlns:a="http://schemas.openxmlformats.org/drawingml/2006/main">
             <a:r>
+              <a:t>- Results_Proposal/figures/figure6_authors_data_wealth_levels.png.</a:t>
+            </a:r>
+          </a:p>
+          <a:p xmlns:a="http://schemas.openxmlformats.org/drawingml/2006/main">
+            <a:r>
+              <a:t>- Data/processed/figure6_authors_data.csv, pre-1982 90th-percentile and post-1982 80th-percentile rows.</a:t>
+            </a:r>
+          </a:p>
+          <a:p xmlns:a="http://schemas.openxmlformats.org/drawingml/2006/main">
+            <a:r>
+              <a:t>- Code/scripts/build_figure6_authors_data.py.</a:t>
+            </a:r>
+          </a:p>
+          <a:p xmlns:a="http://schemas.openxmlformats.org/drawingml/2006/main">
+            <a:r>
+              <a:t>- docs/project/tasks/figure6-replication.md, matched wealth-level interpretation and repeated-cross-section boundary.</a:t>
+            </a:r>
+          </a:p>
+          <a:p xmlns:a="http://schemas.openxmlformats.org/drawingml/2006/main">
+            <a:r>
+              <a:t>[/Sources]</a:t>
+            </a:r>
+          </a:p>
+        </p:txBody>
+      </p:sp>
+      <p:sp>
+        <p:nvSpPr>
+          <p:cNvPr id="4" name="Slide Number Placeholder 3"/>
+          <p:cNvSpPr>
+            <a:spLocks xmlns:a="http://schemas.openxmlformats.org/drawingml/2006/main" noGrp="1"/>
+          </p:cNvSpPr>
+          <p:nvPr>
+            <p:ph type="sldNum" idx="5"/>
+          </p:nvPr>
+        </p:nvSpPr>
+        <p:spPr/>
+        <p:txBody>
+          <a:bodyPr xmlns:a="http://schemas.openxmlformats.org/drawingml/2006/main"/>
+          <a:lstStyle xmlns:a="http://schemas.openxmlformats.org/drawingml/2006/main"/>
+          <a:p xmlns:a="http://schemas.openxmlformats.org/drawingml/2006/main"/>
+        </p:txBody>
+      </p:sp>
+    </p:spTree>
+  </p:cSld>
+  <p:clrMapOvr>
+    <a:masterClrMapping xmlns:a="http://schemas.openxmlformats.org/drawingml/2006/main"/>
+  </p:clrMapOvr>
+</p:notes>
+</file>
+
+<file path=ppt/notesSlides/notesSlide6.xml><?xml version="1.0" encoding="utf-8"?>
+<p:notes xmlns:p="http://schemas.openxmlformats.org/presentationml/2006/main">
+  <p:cSld>
+    <p:spTree>
+      <p:nvGrpSpPr>
+        <p:cNvPr id="1" name=""/>
+        <p:cNvGrpSpPr/>
+        <p:nvPr/>
+      </p:nvGrpSpPr>
+      <p:grpSpPr>
+        <a:xfrm xmlns:a="http://schemas.openxmlformats.org/drawingml/2006/main"/>
+      </p:grpSpPr>
+      <p:sp>
+        <p:nvSpPr>
+          <p:cNvPr id="2" name="Slide Image Placeholder 1"/>
+          <p:cNvSpPr>
+            <a:spLocks xmlns:a="http://schemas.openxmlformats.org/drawingml/2006/main" noGrp="1"/>
+          </p:cNvSpPr>
+          <p:nvPr>
+            <p:ph type="sldImg" idx="0"/>
+          </p:nvPr>
+        </p:nvSpPr>
+        <p:spPr/>
+      </p:sp>
+      <p:sp>
+        <p:nvSpPr>
+          <p:cNvPr id="3" name="Notes Placeholder 2"/>
+          <p:cNvSpPr>
+            <a:spLocks xmlns:a="http://schemas.openxmlformats.org/drawingml/2006/main" noGrp="1"/>
+          </p:cNvSpPr>
+          <p:nvPr>
+            <p:ph type="body" idx="1"/>
+          </p:nvPr>
+        </p:nvSpPr>
+        <p:spPr/>
+        <p:txBody>
+          <a:bodyPr xmlns:a="http://schemas.openxmlformats.org/drawingml/2006/main"/>
+          <a:lstStyle xmlns:a="http://schemas.openxmlformats.org/drawingml/2006/main"/>
+          <a:p xmlns:a="http://schemas.openxmlformats.org/drawingml/2006/main">
+            <a:r>
+              <a:t>[Sources]</a:t>
+            </a:r>
+          </a:p>
+          <a:p xmlns:a="http://schemas.openxmlformats.org/drawingml/2006/main">
+            <a:r>
+              <a:t>- Results_Proposal/figures/figure6_rolling5_heatmap.png.</a:t>
+            </a:r>
+          </a:p>
+          <a:p xmlns:a="http://schemas.openxmlformats.org/drawingml/2006/main">
+            <a:r>
+              <a:t>- Data/processed/figure6_authors_rolling5.csv.</a:t>
+            </a:r>
+          </a:p>
+          <a:p xmlns:a="http://schemas.openxmlformats.org/drawingml/2006/main">
+            <a:r>
+              <a:t>- Code/scripts/build_figure6_authors_data.py.</a:t>
+            </a:r>
+          </a:p>
+          <a:p xmlns:a="http://schemas.openxmlformats.org/drawingml/2006/main">
+            <a:r>
+              <a:t>- docs/project/tasks/figure6-replication.md, time-evolution interpretation and nonmonotonicity boundary.</a:t>
+            </a:r>
+          </a:p>
+          <a:p xmlns:a="http://schemas.openxmlformats.org/drawingml/2006/main">
+            <a:r>
+              <a:t>[/Sources]</a:t>
+            </a:r>
+          </a:p>
+        </p:txBody>
+      </p:sp>
+      <p:sp>
+        <p:nvSpPr>
+          <p:cNvPr id="4" name="Slide Number Placeholder 3"/>
+          <p:cNvSpPr>
+            <a:spLocks xmlns:a="http://schemas.openxmlformats.org/drawingml/2006/main" noGrp="1"/>
+          </p:cNvSpPr>
+          <p:nvPr>
+            <p:ph type="sldNum" idx="5"/>
+          </p:nvPr>
+        </p:nvSpPr>
+        <p:spPr/>
+        <p:txBody>
+          <a:bodyPr xmlns:a="http://schemas.openxmlformats.org/drawingml/2006/main"/>
+          <a:lstStyle xmlns:a="http://schemas.openxmlformats.org/drawingml/2006/main"/>
+          <a:p xmlns:a="http://schemas.openxmlformats.org/drawingml/2006/main"/>
+        </p:txBody>
+      </p:sp>
+    </p:spTree>
+  </p:cSld>
+  <p:clrMapOvr>
+    <a:masterClrMapping xmlns:a="http://schemas.openxmlformats.org/drawingml/2006/main"/>
+  </p:clrMapOvr>
+</p:notes>
+</file>
+
+<file path=ppt/notesSlides/notesSlide7.xml><?xml version="1.0" encoding="utf-8"?>
+<p:notes xmlns:p="http://schemas.openxmlformats.org/presentationml/2006/main">
+  <p:cSld>
+    <p:spTree>
+      <p:nvGrpSpPr>
+        <p:cNvPr id="1" name=""/>
+        <p:cNvGrpSpPr/>
+        <p:nvPr/>
+      </p:nvGrpSpPr>
+      <p:grpSpPr>
+        <a:xfrm xmlns:a="http://schemas.openxmlformats.org/drawingml/2006/main"/>
+      </p:grpSpPr>
+      <p:sp>
+        <p:nvSpPr>
+          <p:cNvPr id="2" name="Slide Image Placeholder 1"/>
+          <p:cNvSpPr>
+            <a:spLocks xmlns:a="http://schemas.openxmlformats.org/drawingml/2006/main" noGrp="1"/>
+          </p:cNvSpPr>
+          <p:nvPr>
+            <p:ph type="sldImg" idx="0"/>
+          </p:nvPr>
+        </p:nvSpPr>
+        <p:spPr/>
+      </p:sp>
+      <p:sp>
+        <p:nvSpPr>
+          <p:cNvPr id="3" name="Notes Placeholder 2"/>
+          <p:cNvSpPr>
+            <a:spLocks xmlns:a="http://schemas.openxmlformats.org/drawingml/2006/main" noGrp="1"/>
+          </p:cNvSpPr>
+          <p:nvPr>
+            <p:ph type="body" idx="1"/>
+          </p:nvPr>
+        </p:nvSpPr>
+        <p:spPr/>
+        <p:txBody>
+          <a:bodyPr xmlns:a="http://schemas.openxmlformats.org/drawingml/2006/main"/>
+          <a:lstStyle xmlns:a="http://schemas.openxmlformats.org/drawingml/2006/main"/>
+          <a:p xmlns:a="http://schemas.openxmlformats.org/drawingml/2006/main">
+            <a:r>
+              <a:t>[Sources]</a:t>
+            </a:r>
+          </a:p>
+          <a:p xmlns:a="http://schemas.openxmlformats.org/drawingml/2006/main">
+            <a:r>
               <a:t>- research_extension_idea_2.md, Stages 2–4 and measurement safeguards.</a:t>
             </a:r>
           </a:p>
@@ -919,7 +1111,7 @@
   </p:cSld>
   <p:clrMap bg1="lt1" tx1="dk1" bg2="lt2" tx2="dk2" accent1="accent1" accent2="accent2" accent3="accent3" accent4="accent4" accent5="accent5" accent6="accent6" hlink="hlink" folHlink="folHlink"/>
   <p:sldLayoutIdLst>
-    <p:sldLayoutId xmlns:r="http://schemas.openxmlformats.org/officeDocument/2006/relationships" id="2147483649" r:id="R2da19cacf28d46b7"/>
+    <p:sldLayoutId xmlns:r="http://schemas.openxmlformats.org/officeDocument/2006/relationships" id="2147483649" r:id="Racca190a6a35420d"/>
   </p:sldLayoutIdLst>
   <p:txStyles>
     <p:titleStyle>
@@ -2971,7 +3163,7 @@
       </p:sp>
       <p:graphicFrame>
         <p:nvGraphicFramePr>
-          <p:cNvPr id="18" name="Chart"/>
+          <p:cNvPr id="20" name="Chart"/>
           <p:cNvGraphicFramePr/>
           <p:nvPr/>
         </p:nvGraphicFramePr>
@@ -2981,7 +3173,7 @@
         </p:xfrm>
         <a:graphic xmlns:a="http://schemas.openxmlformats.org/drawingml/2006/main">
           <a:graphicData uri="http://schemas.openxmlformats.org/drawingml/2006/chart">
-            <c:chart xmlns:r="http://schemas.openxmlformats.org/officeDocument/2006/relationships" xmlns:c="http://schemas.openxmlformats.org/drawingml/2006/chart" r:id="Re94efa8f083247c8"/>
+            <c:chart xmlns:r="http://schemas.openxmlformats.org/officeDocument/2006/relationships" xmlns:c="http://schemas.openxmlformats.org/drawingml/2006/chart" r:id="R667993c3028443a6"/>
           </a:graphicData>
         </a:graphic>
       </p:graphicFrame>
@@ -3667,7 +3859,7 @@
       </p:sp>
       <p:graphicFrame>
         <p:nvGraphicFramePr>
-          <p:cNvPr id="18" name="Chart"/>
+          <p:cNvPr id="20" name="Chart"/>
           <p:cNvGraphicFramePr/>
           <p:nvPr/>
         </p:nvGraphicFramePr>
@@ -3677,7 +3869,7 @@
         </p:xfrm>
         <a:graphic xmlns:a="http://schemas.openxmlformats.org/drawingml/2006/main">
           <a:graphicData uri="http://schemas.openxmlformats.org/drawingml/2006/chart">
-            <c:chart xmlns:r="http://schemas.openxmlformats.org/officeDocument/2006/relationships" xmlns:c="http://schemas.openxmlformats.org/drawingml/2006/chart" r:id="Ra69fe7b1057c41de"/>
+            <c:chart xmlns:r="http://schemas.openxmlformats.org/officeDocument/2006/relationships" xmlns:c="http://schemas.openxmlformats.org/drawingml/2006/chart" r:id="R297dbef0ed7c4e73"/>
           </a:graphicData>
         </a:graphic>
       </p:graphicFrame>
@@ -4363,7 +4555,7 @@
       </p:sp>
       <p:graphicFrame>
         <p:nvGraphicFramePr>
-          <p:cNvPr id="19" name="Chart"/>
+          <p:cNvPr id="21" name="Chart"/>
           <p:cNvGraphicFramePr/>
           <p:nvPr/>
         </p:nvGraphicFramePr>
@@ -4373,7 +4565,7 @@
         </p:xfrm>
         <a:graphic xmlns:a="http://schemas.openxmlformats.org/drawingml/2006/main">
           <a:graphicData uri="http://schemas.openxmlformats.org/drawingml/2006/chart">
-            <c:chart xmlns:r="http://schemas.openxmlformats.org/officeDocument/2006/relationships" xmlns:c="http://schemas.openxmlformats.org/drawingml/2006/chart" r:id="R910c68f349d24a65"/>
+            <c:chart xmlns:r="http://schemas.openxmlformats.org/officeDocument/2006/relationships" xmlns:c="http://schemas.openxmlformats.org/drawingml/2006/chart" r:id="R31a2c9c79c0f4610"/>
           </a:graphicData>
         </a:graphic>
       </p:graphicFrame>
@@ -4904,10 +5096,10 @@
       </p:grpSpPr>
       <p:sp>
         <p:nvSpPr>
-          <p:cNvPr id="19" name="eyebrow-5">
-            <a:extLst xmlns:a="http://schemas.openxmlformats.org/drawingml/2006/main">
-              <a:ext uri="{FF2B5EF4-FFF2-40B4-BE49-F238E27FC236}">
-                <a16:creationId xmlns:a16="http://schemas.microsoft.com/office/drawing/2014/main" id="{B7E82457-90C6-4314-BA41-630C35AF3260}"/>
+          <p:cNvPr id="15" name="eyebrow-4">
+            <a:extLst xmlns:a="http://schemas.openxmlformats.org/drawingml/2006/main">
+              <a:ext uri="{FF2B5EF4-FFF2-40B4-BE49-F238E27FC236}">
+                <a16:creationId xmlns:a16="http://schemas.microsoft.com/office/drawing/2014/main" id="{04D27481-2D51-4FDC-A458-E50B46BAA204}"/>
               </a:ext>
             </a:extLst>
           </p:cNvPr>
@@ -4966,10 +5158,10 @@
       </p:sp>
       <p:sp>
         <p:nvSpPr>
-          <p:cNvPr id="2" name="page-5">
-            <a:extLst xmlns:a="http://schemas.openxmlformats.org/drawingml/2006/main">
-              <a:ext uri="{FF2B5EF4-FFF2-40B4-BE49-F238E27FC236}">
-                <a16:creationId xmlns:a16="http://schemas.microsoft.com/office/drawing/2014/main" id="{632A8695-AB68-4847-9051-1E65BC22DF54}"/>
+          <p:cNvPr id="2" name="page-4">
+            <a:extLst xmlns:a="http://schemas.openxmlformats.org/drawingml/2006/main">
+              <a:ext uri="{FF2B5EF4-FFF2-40B4-BE49-F238E27FC236}">
+                <a16:creationId xmlns:a16="http://schemas.microsoft.com/office/drawing/2014/main" id="{3FBCA310-3DE7-4459-A68A-7A7321114CCC}"/>
               </a:ext>
             </a:extLst>
           </p:cNvPr>
@@ -5022,6 +5214,1534 @@
                 <a:cs typeface="Calibri"/>
               </a:rPr>
               <a:t>05</a:t>
+            </a:r>
+          </a:p>
+        </p:txBody>
+      </p:sp>
+      <p:sp>
+        <p:nvSpPr>
+          <p:cNvPr id="3" name="title-4">
+            <a:extLst xmlns:a="http://schemas.openxmlformats.org/drawingml/2006/main">
+              <a:ext uri="{FF2B5EF4-FFF2-40B4-BE49-F238E27FC236}">
+                <a16:creationId xmlns:a16="http://schemas.microsoft.com/office/drawing/2014/main" id="{13C7AD41-C051-4BE1-B3DF-9419811B0666}"/>
+              </a:ext>
+            </a:extLst>
+          </p:cNvPr>
+          <p:cNvSpPr>
+            <a:spLocks xmlns:a="http://schemas.openxmlformats.org/drawingml/2006/main" noGrp="1"/>
+          </p:cNvSpPr>
+          <p:nvPr/>
+        </p:nvSpPr>
+        <p:spPr>
+          <a:xfrm xmlns:a="http://schemas.openxmlformats.org/drawingml/2006/main">
+            <a:off x="685800" y="657225"/>
+            <a:ext cx="10572750" cy="552450"/>
+          </a:xfrm>
+          <a:prstGeom xmlns:a="http://schemas.openxmlformats.org/drawingml/2006/main" prst="rect">
+            <a:avLst/>
+          </a:prstGeom>
+          <a:noFill xmlns:a="http://schemas.openxmlformats.org/drawingml/2006/main"/>
+          <a:ln xmlns:a="http://schemas.openxmlformats.org/drawingml/2006/main" w="0">
+            <a:noFill/>
+            <a:prstDash val="solid"/>
+          </a:ln>
+        </p:spPr>
+        <p:txBody>
+          <a:bodyPr xmlns:a="http://schemas.openxmlformats.org/drawingml/2006/main" wrap="none" lIns="0" tIns="0" rIns="0" bIns="0" anchor="t">
+            <a:noAutofit/>
+          </a:bodyPr>
+          <a:lstStyle xmlns:a="http://schemas.openxmlformats.org/drawingml/2006/main"/>
+          <a:p xmlns:a="http://schemas.openxmlformats.org/drawingml/2006/main">
+            <a:pPr algn="l">
+              <a:lnSpc>
+                <a:spcPct val="100000"/>
+              </a:lnSpc>
+              <a:buNone/>
+              <a:defRPr sz="3525" b="0">
+                <a:solidFill>
+                  <a:srgbClr val="12304A"/>
+                </a:solidFill>
+                <a:latin typeface="Calibri Light"/>
+                <a:ea typeface="Calibri Light"/>
+                <a:cs typeface="Calibri Light"/>
+              </a:defRPr>
+            </a:pPr>
+            <a:r>
+              <a:rPr sz="3525" b="0">
+                <a:solidFill>
+                  <a:srgbClr val="12304A"/>
+                </a:solidFill>
+                <a:latin typeface="Calibri Light"/>
+                <a:ea typeface="Calibri Light"/>
+                <a:cs typeface="Calibri Light"/>
+              </a:rPr>
+              <a:t>Similar wealth carries much lower saving after 1982</a:t>
+            </a:r>
+          </a:p>
+        </p:txBody>
+      </p:sp>
+      <p:sp>
+        <p:nvSpPr>
+          <p:cNvPr id="4" name="title-rule-4">
+            <a:extLst xmlns:a="http://schemas.openxmlformats.org/drawingml/2006/main">
+              <a:ext uri="{FF2B5EF4-FFF2-40B4-BE49-F238E27FC236}">
+                <a16:creationId xmlns:a16="http://schemas.microsoft.com/office/drawing/2014/main" id="{B937DE71-60F9-4EA0-8DBE-8BD108413904}"/>
+              </a:ext>
+            </a:extLst>
+          </p:cNvPr>
+          <p:cNvSpPr>
+            <a:spLocks xmlns:a="http://schemas.openxmlformats.org/drawingml/2006/main" noGrp="1"/>
+          </p:cNvSpPr>
+          <p:nvPr/>
+        </p:nvSpPr>
+        <p:spPr>
+          <a:xfrm xmlns:a="http://schemas.openxmlformats.org/drawingml/2006/main">
+            <a:off x="685800" y="1285875"/>
+            <a:ext cx="10820400" cy="28575"/>
+          </a:xfrm>
+          <a:prstGeom xmlns:a="http://schemas.openxmlformats.org/drawingml/2006/main" prst="rect">
+            <a:avLst/>
+          </a:prstGeom>
+          <a:solidFill xmlns:a="http://schemas.openxmlformats.org/drawingml/2006/main">
+            <a:srgbClr val="C85200"/>
+          </a:solidFill>
+          <a:ln xmlns:a="http://schemas.openxmlformats.org/drawingml/2006/main" w="0">
+            <a:noFill/>
+            <a:prstDash val="solid"/>
+          </a:ln>
+        </p:spPr>
+      </p:sp>
+      <p:sp>
+        <p:nvSpPr>
+          <p:cNvPr id="6" name="unveiling-callout">
+            <a:extLst xmlns:a="http://schemas.openxmlformats.org/drawingml/2006/main">
+              <a:ext uri="{FF2B5EF4-FFF2-40B4-BE49-F238E27FC236}">
+                <a16:creationId xmlns:a16="http://schemas.microsoft.com/office/drawing/2014/main" id="{46BEFB9F-3CE7-4B0F-B11B-8442C71F68B6}"/>
+              </a:ext>
+            </a:extLst>
+          </p:cNvPr>
+          <p:cNvSpPr>
+            <a:spLocks xmlns:a="http://schemas.openxmlformats.org/drawingml/2006/main" noGrp="1"/>
+          </p:cNvSpPr>
+          <p:nvPr/>
+        </p:nvSpPr>
+        <p:spPr>
+          <a:xfrm xmlns:a="http://schemas.openxmlformats.org/drawingml/2006/main">
+            <a:off x="9096375" y="1809750"/>
+            <a:ext cx="2333625" cy="2724150"/>
+          </a:xfrm>
+          <a:prstGeom xmlns:a="http://schemas.openxmlformats.org/drawingml/2006/main" prst="rect">
+            <a:avLst/>
+          </a:prstGeom>
+          <a:solidFill xmlns:a="http://schemas.openxmlformats.org/drawingml/2006/main">
+            <a:srgbClr val="EAF2F7"/>
+          </a:solidFill>
+          <a:ln xmlns:a="http://schemas.openxmlformats.org/drawingml/2006/main" w="0">
+            <a:noFill/>
+            <a:prstDash val="solid"/>
+          </a:ln>
+        </p:spPr>
+      </p:sp>
+      <p:sp>
+        <p:nvSpPr>
+          <p:cNvPr id="7" name="unveiling-callout-head">
+            <a:extLst xmlns:a="http://schemas.openxmlformats.org/drawingml/2006/main">
+              <a:ext uri="{FF2B5EF4-FFF2-40B4-BE49-F238E27FC236}">
+                <a16:creationId xmlns:a16="http://schemas.microsoft.com/office/drawing/2014/main" id="{F66C261D-099D-4A04-A8D3-9BB759A6F493}"/>
+              </a:ext>
+            </a:extLst>
+          </p:cNvPr>
+          <p:cNvSpPr>
+            <a:spLocks xmlns:a="http://schemas.openxmlformats.org/drawingml/2006/main" noGrp="1"/>
+          </p:cNvSpPr>
+          <p:nvPr/>
+        </p:nvSpPr>
+        <p:spPr>
+          <a:xfrm xmlns:a="http://schemas.openxmlformats.org/drawingml/2006/main">
+            <a:off x="9315450" y="2038350"/>
+            <a:ext cx="1924050" cy="342900"/>
+          </a:xfrm>
+          <a:prstGeom xmlns:a="http://schemas.openxmlformats.org/drawingml/2006/main" prst="rect">
+            <a:avLst/>
+          </a:prstGeom>
+          <a:noFill xmlns:a="http://schemas.openxmlformats.org/drawingml/2006/main"/>
+          <a:ln xmlns:a="http://schemas.openxmlformats.org/drawingml/2006/main" w="0">
+            <a:noFill/>
+            <a:prstDash val="solid"/>
+          </a:ln>
+        </p:spPr>
+        <p:txBody>
+          <a:bodyPr xmlns:a="http://schemas.openxmlformats.org/drawingml/2006/main" wrap="square" lIns="0" tIns="0" rIns="0" bIns="0" anchor="t">
+            <a:noAutofit/>
+          </a:bodyPr>
+          <a:lstStyle xmlns:a="http://schemas.openxmlformats.org/drawingml/2006/main"/>
+          <a:p xmlns:a="http://schemas.openxmlformats.org/drawingml/2006/main">
+            <a:pPr algn="l">
+              <a:lnSpc>
+                <a:spcPct val="100000"/>
+              </a:lnSpc>
+              <a:buNone/>
+              <a:defRPr sz="1650" b="1">
+                <a:solidFill>
+                  <a:srgbClr val="1170AA"/>
+                </a:solidFill>
+                <a:latin typeface="Calibri"/>
+                <a:ea typeface="Calibri"/>
+                <a:cs typeface="Calibri"/>
+              </a:defRPr>
+            </a:pPr>
+            <a:r>
+              <a:rPr sz="1650" b="1">
+                <a:solidFill>
+                  <a:srgbClr val="1170AA"/>
+                </a:solidFill>
+                <a:latin typeface="Calibri"/>
+                <a:ea typeface="Calibri"/>
+                <a:cs typeface="Calibri"/>
+              </a:rPr>
+              <a:t>Comparable mean wealth</a:t>
+            </a:r>
+          </a:p>
+        </p:txBody>
+      </p:sp>
+      <p:sp>
+        <p:nvSpPr>
+          <p:cNvPr id="8" name="unveiling-top1">
+            <a:extLst xmlns:a="http://schemas.openxmlformats.org/drawingml/2006/main">
+              <a:ext uri="{FF2B5EF4-FFF2-40B4-BE49-F238E27FC236}">
+                <a16:creationId xmlns:a16="http://schemas.microsoft.com/office/drawing/2014/main" id="{1E2D59D0-34FC-4666-9356-6AC891D98394}"/>
+              </a:ext>
+            </a:extLst>
+          </p:cNvPr>
+          <p:cNvSpPr>
+            <a:spLocks xmlns:a="http://schemas.openxmlformats.org/drawingml/2006/main" noGrp="1"/>
+          </p:cNvSpPr>
+          <p:nvPr/>
+        </p:nvSpPr>
+        <p:spPr>
+          <a:xfrm xmlns:a="http://schemas.openxmlformats.org/drawingml/2006/main">
+            <a:off x="9315450" y="2590800"/>
+            <a:ext cx="1924050" cy="419100"/>
+          </a:xfrm>
+          <a:prstGeom xmlns:a="http://schemas.openxmlformats.org/drawingml/2006/main" prst="rect">
+            <a:avLst/>
+          </a:prstGeom>
+          <a:noFill xmlns:a="http://schemas.openxmlformats.org/drawingml/2006/main"/>
+          <a:ln xmlns:a="http://schemas.openxmlformats.org/drawingml/2006/main" w="0">
+            <a:noFill/>
+            <a:prstDash val="solid"/>
+          </a:ln>
+        </p:spPr>
+        <p:txBody>
+          <a:bodyPr xmlns:a="http://schemas.openxmlformats.org/drawingml/2006/main" wrap="square" lIns="0" tIns="0" rIns="0" bIns="0" anchor="t">
+            <a:noAutofit/>
+          </a:bodyPr>
+          <a:lstStyle xmlns:a="http://schemas.openxmlformats.org/drawingml/2006/main"/>
+          <a:p xmlns:a="http://schemas.openxmlformats.org/drawingml/2006/main">
+            <a:pPr algn="l">
+              <a:lnSpc>
+                <a:spcPct val="100000"/>
+              </a:lnSpc>
+              <a:buNone/>
+              <a:defRPr sz="2775" b="1">
+                <a:solidFill>
+                  <a:srgbClr val="12304A"/>
+                </a:solidFill>
+                <a:latin typeface="Calibri"/>
+                <a:ea typeface="Calibri"/>
+                <a:cs typeface="Calibri"/>
+              </a:defRPr>
+            </a:pPr>
+            <a:r>
+              <a:rPr sz="2175" b="1">
+                <a:solidFill>
+                  <a:srgbClr val="12304A"/>
+                </a:solidFill>
+                <a:latin typeface="Calibri"/>
+                <a:ea typeface="Calibri"/>
+                <a:cs typeface="Calibri"/>
+              </a:rPr>
+              <a:t>$303k · 31.5%</a:t>
+            </a:r>
+          </a:p>
+        </p:txBody>
+      </p:sp>
+      <p:sp>
+        <p:nvSpPr>
+          <p:cNvPr id="9" name="unveiling-top1-label">
+            <a:extLst xmlns:a="http://schemas.openxmlformats.org/drawingml/2006/main">
+              <a:ext uri="{FF2B5EF4-FFF2-40B4-BE49-F238E27FC236}">
+                <a16:creationId xmlns:a16="http://schemas.microsoft.com/office/drawing/2014/main" id="{6E6C2350-D9B3-4A9E-AD6E-63D6413706CD}"/>
+              </a:ext>
+            </a:extLst>
+          </p:cNvPr>
+          <p:cNvSpPr>
+            <a:spLocks xmlns:a="http://schemas.openxmlformats.org/drawingml/2006/main" noGrp="1"/>
+          </p:cNvSpPr>
+          <p:nvPr/>
+        </p:nvSpPr>
+        <p:spPr>
+          <a:xfrm xmlns:a="http://schemas.openxmlformats.org/drawingml/2006/main">
+            <a:off x="9315450" y="3038475"/>
+            <a:ext cx="1924050" cy="266700"/>
+          </a:xfrm>
+          <a:prstGeom xmlns:a="http://schemas.openxmlformats.org/drawingml/2006/main" prst="rect">
+            <a:avLst/>
+          </a:prstGeom>
+          <a:noFill xmlns:a="http://schemas.openxmlformats.org/drawingml/2006/main"/>
+          <a:ln xmlns:a="http://schemas.openxmlformats.org/drawingml/2006/main" w="0">
+            <a:noFill/>
+            <a:prstDash val="solid"/>
+          </a:ln>
+        </p:spPr>
+        <p:txBody>
+          <a:bodyPr xmlns:a="http://schemas.openxmlformats.org/drawingml/2006/main" wrap="square" lIns="0" tIns="0" rIns="0" bIns="0" anchor="t">
+            <a:noAutofit/>
+          </a:bodyPr>
+          <a:lstStyle xmlns:a="http://schemas.openxmlformats.org/drawingml/2006/main"/>
+          <a:p xmlns:a="http://schemas.openxmlformats.org/drawingml/2006/main">
+            <a:pPr algn="l">
+              <a:lnSpc>
+                <a:spcPct val="100000"/>
+              </a:lnSpc>
+              <a:buNone/>
+              <a:defRPr sz="1500" b="0">
+                <a:solidFill>
+                  <a:srgbClr val="53616E"/>
+                </a:solidFill>
+                <a:latin typeface="Calibri"/>
+                <a:ea typeface="Calibri"/>
+                <a:cs typeface="Calibri"/>
+              </a:defRPr>
+            </a:pPr>
+            <a:r>
+              <a:rPr sz="1200" b="0">
+                <a:solidFill>
+                  <a:srgbClr val="53616E"/>
+                </a:solidFill>
+                <a:latin typeface="Calibri"/>
+                <a:ea typeface="Calibri"/>
+                <a:cs typeface="Calibri"/>
+              </a:rPr>
+              <a:t>Pre: 90th pct.</a:t>
+            </a:r>
+          </a:p>
+        </p:txBody>
+      </p:sp>
+      <p:sp>
+        <p:nvSpPr>
+          <p:cNvPr id="10" name="unveiling-next40">
+            <a:extLst xmlns:a="http://schemas.openxmlformats.org/drawingml/2006/main">
+              <a:ext uri="{FF2B5EF4-FFF2-40B4-BE49-F238E27FC236}">
+                <a16:creationId xmlns:a16="http://schemas.microsoft.com/office/drawing/2014/main" id="{A59386EE-960A-49E3-B63F-D6D6A0076EBC}"/>
+              </a:ext>
+            </a:extLst>
+          </p:cNvPr>
+          <p:cNvSpPr>
+            <a:spLocks xmlns:a="http://schemas.openxmlformats.org/drawingml/2006/main" noGrp="1"/>
+          </p:cNvSpPr>
+          <p:nvPr/>
+        </p:nvSpPr>
+        <p:spPr>
+          <a:xfrm xmlns:a="http://schemas.openxmlformats.org/drawingml/2006/main">
+            <a:off x="9315450" y="3495675"/>
+            <a:ext cx="1924050" cy="419100"/>
+          </a:xfrm>
+          <a:prstGeom xmlns:a="http://schemas.openxmlformats.org/drawingml/2006/main" prst="rect">
+            <a:avLst/>
+          </a:prstGeom>
+          <a:noFill xmlns:a="http://schemas.openxmlformats.org/drawingml/2006/main"/>
+          <a:ln xmlns:a="http://schemas.openxmlformats.org/drawingml/2006/main" w="0">
+            <a:noFill/>
+            <a:prstDash val="solid"/>
+          </a:ln>
+        </p:spPr>
+        <p:txBody>
+          <a:bodyPr xmlns:a="http://schemas.openxmlformats.org/drawingml/2006/main" wrap="square" lIns="0" tIns="0" rIns="0" bIns="0" anchor="t">
+            <a:noAutofit/>
+          </a:bodyPr>
+          <a:lstStyle xmlns:a="http://schemas.openxmlformats.org/drawingml/2006/main"/>
+          <a:p xmlns:a="http://schemas.openxmlformats.org/drawingml/2006/main">
+            <a:pPr algn="l">
+              <a:lnSpc>
+                <a:spcPct val="100000"/>
+              </a:lnSpc>
+              <a:buNone/>
+              <a:defRPr sz="2775" b="1">
+                <a:solidFill>
+                  <a:srgbClr val="12304A"/>
+                </a:solidFill>
+                <a:latin typeface="Calibri"/>
+                <a:ea typeface="Calibri"/>
+                <a:cs typeface="Calibri"/>
+              </a:defRPr>
+            </a:pPr>
+            <a:r>
+              <a:rPr sz="2175" b="1">
+                <a:solidFill>
+                  <a:srgbClr val="12304A"/>
+                </a:solidFill>
+                <a:latin typeface="Calibri"/>
+                <a:ea typeface="Calibri"/>
+                <a:cs typeface="Calibri"/>
+              </a:rPr>
+              <a:t>$286k · 7.4%</a:t>
+            </a:r>
+          </a:p>
+        </p:txBody>
+      </p:sp>
+      <p:sp>
+        <p:nvSpPr>
+          <p:cNvPr id="11" name="unveiling-next40-label">
+            <a:extLst xmlns:a="http://schemas.openxmlformats.org/drawingml/2006/main">
+              <a:ext uri="{FF2B5EF4-FFF2-40B4-BE49-F238E27FC236}">
+                <a16:creationId xmlns:a16="http://schemas.microsoft.com/office/drawing/2014/main" id="{F774C9D0-7893-4A1F-A5E2-A5D98AF74A9F}"/>
+              </a:ext>
+            </a:extLst>
+          </p:cNvPr>
+          <p:cNvSpPr>
+            <a:spLocks xmlns:a="http://schemas.openxmlformats.org/drawingml/2006/main" noGrp="1"/>
+          </p:cNvSpPr>
+          <p:nvPr/>
+        </p:nvSpPr>
+        <p:spPr>
+          <a:xfrm xmlns:a="http://schemas.openxmlformats.org/drawingml/2006/main">
+            <a:off x="9315450" y="3943350"/>
+            <a:ext cx="1924050" cy="266700"/>
+          </a:xfrm>
+          <a:prstGeom xmlns:a="http://schemas.openxmlformats.org/drawingml/2006/main" prst="rect">
+            <a:avLst/>
+          </a:prstGeom>
+          <a:noFill xmlns:a="http://schemas.openxmlformats.org/drawingml/2006/main"/>
+          <a:ln xmlns:a="http://schemas.openxmlformats.org/drawingml/2006/main" w="0">
+            <a:noFill/>
+            <a:prstDash val="solid"/>
+          </a:ln>
+        </p:spPr>
+        <p:txBody>
+          <a:bodyPr xmlns:a="http://schemas.openxmlformats.org/drawingml/2006/main" wrap="square" lIns="0" tIns="0" rIns="0" bIns="0" anchor="t">
+            <a:noAutofit/>
+          </a:bodyPr>
+          <a:lstStyle xmlns:a="http://schemas.openxmlformats.org/drawingml/2006/main"/>
+          <a:p xmlns:a="http://schemas.openxmlformats.org/drawingml/2006/main">
+            <a:pPr algn="l">
+              <a:lnSpc>
+                <a:spcPct val="100000"/>
+              </a:lnSpc>
+              <a:buNone/>
+              <a:defRPr sz="1500" b="0">
+                <a:solidFill>
+                  <a:srgbClr val="53616E"/>
+                </a:solidFill>
+                <a:latin typeface="Calibri"/>
+                <a:ea typeface="Calibri"/>
+                <a:cs typeface="Calibri"/>
+              </a:defRPr>
+            </a:pPr>
+            <a:r>
+              <a:rPr sz="1200" b="0">
+                <a:solidFill>
+                  <a:srgbClr val="53616E"/>
+                </a:solidFill>
+                <a:latin typeface="Calibri"/>
+                <a:ea typeface="Calibri"/>
+                <a:cs typeface="Calibri"/>
+              </a:rPr>
+              <a:t>Post: 80th pct.</a:t>
+            </a:r>
+          </a:p>
+        </p:txBody>
+      </p:sp>
+      <p:sp>
+        <p:nvSpPr>
+          <p:cNvPr id="12" name="implication-band-4">
+            <a:extLst xmlns:a="http://schemas.openxmlformats.org/drawingml/2006/main">
+              <a:ext uri="{FF2B5EF4-FFF2-40B4-BE49-F238E27FC236}">
+                <a16:creationId xmlns:a16="http://schemas.microsoft.com/office/drawing/2014/main" id="{F99C7C96-A626-4ED9-AA36-1DFFFFE09157}"/>
+              </a:ext>
+            </a:extLst>
+          </p:cNvPr>
+          <p:cNvSpPr>
+            <a:spLocks xmlns:a="http://schemas.openxmlformats.org/drawingml/2006/main" noGrp="1"/>
+          </p:cNvSpPr>
+          <p:nvPr/>
+        </p:nvSpPr>
+        <p:spPr>
+          <a:xfrm xmlns:a="http://schemas.openxmlformats.org/drawingml/2006/main">
+            <a:off x="685800" y="5638800"/>
+            <a:ext cx="10820400" cy="590550"/>
+          </a:xfrm>
+          <a:prstGeom xmlns:a="http://schemas.openxmlformats.org/drawingml/2006/main" prst="rect">
+            <a:avLst/>
+          </a:prstGeom>
+          <a:solidFill xmlns:a="http://schemas.openxmlformats.org/drawingml/2006/main">
+            <a:srgbClr val="EAF2F7"/>
+          </a:solidFill>
+          <a:ln xmlns:a="http://schemas.openxmlformats.org/drawingml/2006/main" w="0">
+            <a:noFill/>
+            <a:prstDash val="solid"/>
+          </a:ln>
+        </p:spPr>
+      </p:sp>
+      <p:sp>
+        <p:nvSpPr>
+          <p:cNvPr id="13" name="implication-4">
+            <a:extLst xmlns:a="http://schemas.openxmlformats.org/drawingml/2006/main">
+              <a:ext uri="{FF2B5EF4-FFF2-40B4-BE49-F238E27FC236}">
+                <a16:creationId xmlns:a16="http://schemas.microsoft.com/office/drawing/2014/main" id="{7927E323-74AF-4077-B4ED-E330091CEBD3}"/>
+              </a:ext>
+            </a:extLst>
+          </p:cNvPr>
+          <p:cNvSpPr>
+            <a:spLocks xmlns:a="http://schemas.openxmlformats.org/drawingml/2006/main" noGrp="1"/>
+          </p:cNvSpPr>
+          <p:nvPr/>
+        </p:nvSpPr>
+        <p:spPr>
+          <a:xfrm xmlns:a="http://schemas.openxmlformats.org/drawingml/2006/main">
+            <a:off x="895350" y="5781675"/>
+            <a:ext cx="10401300" cy="323850"/>
+          </a:xfrm>
+          <a:prstGeom xmlns:a="http://schemas.openxmlformats.org/drawingml/2006/main" prst="rect">
+            <a:avLst/>
+          </a:prstGeom>
+          <a:noFill xmlns:a="http://schemas.openxmlformats.org/drawingml/2006/main"/>
+          <a:ln xmlns:a="http://schemas.openxmlformats.org/drawingml/2006/main" w="0">
+            <a:noFill/>
+            <a:prstDash val="solid"/>
+          </a:ln>
+        </p:spPr>
+        <p:txBody>
+          <a:bodyPr xmlns:a="http://schemas.openxmlformats.org/drawingml/2006/main" wrap="square" lIns="0" tIns="0" rIns="0" bIns="0" anchor="ctr">
+            <a:noAutofit/>
+          </a:bodyPr>
+          <a:lstStyle xmlns:a="http://schemas.openxmlformats.org/drawingml/2006/main"/>
+          <a:p xmlns:a="http://schemas.openxmlformats.org/drawingml/2006/main">
+            <a:pPr algn="l">
+              <a:lnSpc>
+                <a:spcPct val="100000"/>
+              </a:lnSpc>
+              <a:buNone/>
+              <a:defRPr sz="1725" b="1">
+                <a:solidFill>
+                  <a:srgbClr val="12304A"/>
+                </a:solidFill>
+                <a:latin typeface="Calibri"/>
+                <a:ea typeface="Calibri"/>
+                <a:cs typeface="Calibri"/>
+              </a:defRPr>
+            </a:pPr>
+            <a:r>
+              <a:rPr sz="1725" b="1">
+                <a:solidFill>
+                  <a:srgbClr val="12304A"/>
+                </a:solidFill>
+                <a:latin typeface="Calibri"/>
+                <a:ea typeface="Calibri"/>
+                <a:cs typeface="Calibri"/>
+              </a:rPr>
+              <a:t>The saving-rate decline is not only a change in percentile labels: similarly wealthy cohorts save much less in the later period.</a:t>
+            </a:r>
+          </a:p>
+        </p:txBody>
+      </p:sp>
+      <p:sp>
+        <p:nvSpPr>
+          <p:cNvPr id="14" name="source-4">
+            <a:extLst xmlns:a="http://schemas.openxmlformats.org/drawingml/2006/main">
+              <a:ext uri="{FF2B5EF4-FFF2-40B4-BE49-F238E27FC236}">
+                <a16:creationId xmlns:a16="http://schemas.microsoft.com/office/drawing/2014/main" id="{537BBD31-6288-48F6-9A86-03C97EDBCA95}"/>
+              </a:ext>
+            </a:extLst>
+          </p:cNvPr>
+          <p:cNvSpPr>
+            <a:spLocks xmlns:a="http://schemas.openxmlformats.org/drawingml/2006/main" noGrp="1"/>
+          </p:cNvSpPr>
+          <p:nvPr/>
+        </p:nvSpPr>
+        <p:spPr>
+          <a:xfrm xmlns:a="http://schemas.openxmlformats.org/drawingml/2006/main">
+            <a:off x="685800" y="6381750"/>
+            <a:ext cx="10820400" cy="228600"/>
+          </a:xfrm>
+          <a:prstGeom xmlns:a="http://schemas.openxmlformats.org/drawingml/2006/main" prst="rect">
+            <a:avLst/>
+          </a:prstGeom>
+          <a:noFill xmlns:a="http://schemas.openxmlformats.org/drawingml/2006/main"/>
+          <a:ln xmlns:a="http://schemas.openxmlformats.org/drawingml/2006/main" w="0">
+            <a:noFill/>
+            <a:prstDash val="solid"/>
+          </a:ln>
+        </p:spPr>
+        <p:txBody>
+          <a:bodyPr xmlns:a="http://schemas.openxmlformats.org/drawingml/2006/main" wrap="square" lIns="0" tIns="0" rIns="0" bIns="0" anchor="t">
+            <a:noAutofit/>
+          </a:bodyPr>
+          <a:lstStyle xmlns:a="http://schemas.openxmlformats.org/drawingml/2006/main"/>
+          <a:p xmlns:a="http://schemas.openxmlformats.org/drawingml/2006/main">
+            <a:pPr algn="l">
+              <a:lnSpc>
+                <a:spcPct val="100000"/>
+              </a:lnSpc>
+              <a:buNone/>
+              <a:defRPr sz="1200" b="0">
+                <a:solidFill>
+                  <a:srgbClr val="53616E"/>
+                </a:solidFill>
+                <a:latin typeface="Calibri"/>
+                <a:ea typeface="Calibri"/>
+                <a:cs typeface="Calibri"/>
+              </a:defRPr>
+            </a:pPr>
+            <a:r>
+              <a:rPr sz="1200" b="0">
+                <a:solidFill>
+                  <a:srgbClr val="53616E"/>
+                </a:solidFill>
+                <a:latin typeface="Calibri"/>
+                <a:ea typeface="Calibri"/>
+                <a:cs typeface="Calibri"/>
+              </a:rPr>
+              <a:t>Source: Figure 6 exact-method reconstruction; cohort means in 2018 dollars, not fixed-dollar bins.</a:t>
+            </a:r>
+          </a:p>
+        </p:txBody>
+      </p:sp>
+      <p:pic>
+        <p:nvPicPr>
+          <p:cNvPr id="30" name=""/>
+          <p:cNvPicPr>
+            <a:picLocks xmlns:a="http://schemas.openxmlformats.org/drawingml/2006/main" noChangeAspect="1"/>
+          </p:cNvPicPr>
+          <p:nvPr/>
+        </p:nvPicPr>
+        <p:blipFill>
+          <a:blip xmlns:r="http://schemas.openxmlformats.org/officeDocument/2006/relationships" xmlns:a="http://schemas.openxmlformats.org/drawingml/2006/main" r:embed="R1ced3a6fac5e41ca"/>
+          <a:stretch xmlns:a="http://schemas.openxmlformats.org/drawingml/2006/main"/>
+        </p:blipFill>
+        <p:spPr>
+          <a:xfrm xmlns:a="http://schemas.openxmlformats.org/drawingml/2006/main">
+            <a:off x="1465580" y="1504950"/>
+            <a:ext cx="6612890" cy="3905250"/>
+          </a:xfrm>
+          <a:prstGeom xmlns:a="http://schemas.openxmlformats.org/drawingml/2006/main" prst="rect">
+            <a:avLst/>
+          </a:prstGeom>
+        </p:spPr>
+      </p:pic>
+    </p:spTree>
+    <p:extLst>
+      <p:ext uri="{BB962C8B-B14F-4D97-AF65-F5344CB8AC3E}">
+        <p14:creationId xmlns:p14="http://schemas.microsoft.com/office/powerpoint/2010/main" val="667014454"/>
+      </p:ext>
+    </p:extLst>
+  </p:cSld>
+</p:sld>
+</file>
+
+<file path=ppt/slides/slide6.xml><?xml version="1.0" encoding="utf-8"?>
+<p:sld xmlns:p="http://schemas.openxmlformats.org/presentationml/2006/main">
+  <p:cSld>
+    <p:bg>
+      <p:bgPr>
+        <a:solidFill xmlns:a="http://schemas.openxmlformats.org/drawingml/2006/main">
+          <a:srgbClr val="FFFFFF"/>
+        </a:solidFill>
+      </p:bgPr>
+    </p:bg>
+    <p:spTree>
+      <p:nvGrpSpPr>
+        <p:cNvPr id="1" name=""/>
+        <p:cNvGrpSpPr/>
+        <p:nvPr/>
+      </p:nvGrpSpPr>
+      <p:grpSpPr>
+        <a:xfrm xmlns:a="http://schemas.openxmlformats.org/drawingml/2006/main"/>
+      </p:grpSpPr>
+      <p:sp>
+        <p:nvSpPr>
+          <p:cNvPr id="15" name="eyebrow-4">
+            <a:extLst xmlns:a="http://schemas.openxmlformats.org/drawingml/2006/main">
+              <a:ext uri="{FF2B5EF4-FFF2-40B4-BE49-F238E27FC236}">
+                <a16:creationId xmlns:a16="http://schemas.microsoft.com/office/drawing/2014/main" id="{04D27481-2D51-4FDC-A458-E50B46BAA204}"/>
+              </a:ext>
+            </a:extLst>
+          </p:cNvPr>
+          <p:cNvSpPr>
+            <a:spLocks xmlns:a="http://schemas.openxmlformats.org/drawingml/2006/main" noGrp="1"/>
+          </p:cNvSpPr>
+          <p:nvPr/>
+        </p:nvSpPr>
+        <p:spPr>
+          <a:xfrm xmlns:a="http://schemas.openxmlformats.org/drawingml/2006/main">
+            <a:off x="685800" y="323850"/>
+            <a:ext cx="6667500" cy="228600"/>
+          </a:xfrm>
+          <a:prstGeom xmlns:a="http://schemas.openxmlformats.org/drawingml/2006/main" prst="rect">
+            <a:avLst/>
+          </a:prstGeom>
+          <a:noFill xmlns:a="http://schemas.openxmlformats.org/drawingml/2006/main"/>
+          <a:ln xmlns:a="http://schemas.openxmlformats.org/drawingml/2006/main" w="0">
+            <a:noFill/>
+            <a:prstDash val="solid"/>
+          </a:ln>
+        </p:spPr>
+        <p:txBody>
+          <a:bodyPr xmlns:a="http://schemas.openxmlformats.org/drawingml/2006/main" wrap="square" lIns="0" tIns="0" rIns="0" bIns="0" anchor="t">
+            <a:noAutofit/>
+          </a:bodyPr>
+          <a:lstStyle xmlns:a="http://schemas.openxmlformats.org/drawingml/2006/main"/>
+          <a:p xmlns:a="http://schemas.openxmlformats.org/drawingml/2006/main">
+            <a:pPr algn="l">
+              <a:lnSpc>
+                <a:spcPct val="100000"/>
+              </a:lnSpc>
+              <a:buNone/>
+              <a:defRPr sz="1200" b="1">
+                <a:solidFill>
+                  <a:srgbClr val="C85200"/>
+                </a:solidFill>
+                <a:latin typeface="Calibri"/>
+                <a:ea typeface="Calibri"/>
+                <a:cs typeface="Calibri"/>
+              </a:defRPr>
+            </a:pPr>
+            <a:r>
+              <a:rPr sz="1200" b="1">
+                <a:solidFill>
+                  <a:srgbClr val="C85200"/>
+                </a:solidFill>
+                <a:latin typeface="Calibri"/>
+                <a:ea typeface="Calibri"/>
+                <a:cs typeface="Calibri"/>
+              </a:rPr>
+              <a:t>RESEARCH EXTENSION  ·  PRELIMINARY EVIDENCE</a:t>
+            </a:r>
+          </a:p>
+        </p:txBody>
+      </p:sp>
+      <p:sp>
+        <p:nvSpPr>
+          <p:cNvPr id="2" name="page-4">
+            <a:extLst xmlns:a="http://schemas.openxmlformats.org/drawingml/2006/main">
+              <a:ext uri="{FF2B5EF4-FFF2-40B4-BE49-F238E27FC236}">
+                <a16:creationId xmlns:a16="http://schemas.microsoft.com/office/drawing/2014/main" id="{3FBCA310-3DE7-4459-A68A-7A7321114CCC}"/>
+              </a:ext>
+            </a:extLst>
+          </p:cNvPr>
+          <p:cNvSpPr>
+            <a:spLocks xmlns:a="http://schemas.openxmlformats.org/drawingml/2006/main" noGrp="1"/>
+          </p:cNvSpPr>
+          <p:nvPr/>
+        </p:nvSpPr>
+        <p:spPr>
+          <a:xfrm xmlns:a="http://schemas.openxmlformats.org/drawingml/2006/main">
+            <a:off x="11239500" y="314325"/>
+            <a:ext cx="266700" cy="228600"/>
+          </a:xfrm>
+          <a:prstGeom xmlns:a="http://schemas.openxmlformats.org/drawingml/2006/main" prst="rect">
+            <a:avLst/>
+          </a:prstGeom>
+          <a:noFill xmlns:a="http://schemas.openxmlformats.org/drawingml/2006/main"/>
+          <a:ln xmlns:a="http://schemas.openxmlformats.org/drawingml/2006/main" w="0">
+            <a:noFill/>
+            <a:prstDash val="solid"/>
+          </a:ln>
+        </p:spPr>
+        <p:txBody>
+          <a:bodyPr xmlns:a="http://schemas.openxmlformats.org/drawingml/2006/main" wrap="square" lIns="0" tIns="0" rIns="0" bIns="0" anchor="t">
+            <a:noAutofit/>
+          </a:bodyPr>
+          <a:lstStyle xmlns:a="http://schemas.openxmlformats.org/drawingml/2006/main"/>
+          <a:p xmlns:a="http://schemas.openxmlformats.org/drawingml/2006/main">
+            <a:pPr algn="r">
+              <a:lnSpc>
+                <a:spcPct val="100000"/>
+              </a:lnSpc>
+              <a:buNone/>
+              <a:defRPr sz="1200" b="0">
+                <a:solidFill>
+                  <a:srgbClr val="53616E"/>
+                </a:solidFill>
+                <a:latin typeface="Calibri"/>
+                <a:ea typeface="Calibri"/>
+                <a:cs typeface="Calibri"/>
+              </a:defRPr>
+            </a:pPr>
+            <a:r>
+              <a:rPr sz="1200" b="0">
+                <a:solidFill>
+                  <a:srgbClr val="53616E"/>
+                </a:solidFill>
+                <a:latin typeface="Calibri"/>
+                <a:ea typeface="Calibri"/>
+                <a:cs typeface="Calibri"/>
+              </a:rPr>
+              <a:t>06</a:t>
+            </a:r>
+          </a:p>
+        </p:txBody>
+      </p:sp>
+      <p:sp>
+        <p:nvSpPr>
+          <p:cNvPr id="3" name="title-4">
+            <a:extLst xmlns:a="http://schemas.openxmlformats.org/drawingml/2006/main">
+              <a:ext uri="{FF2B5EF4-FFF2-40B4-BE49-F238E27FC236}">
+                <a16:creationId xmlns:a16="http://schemas.microsoft.com/office/drawing/2014/main" id="{13C7AD41-C051-4BE1-B3DF-9419811B0666}"/>
+              </a:ext>
+            </a:extLst>
+          </p:cNvPr>
+          <p:cNvSpPr>
+            <a:spLocks xmlns:a="http://schemas.openxmlformats.org/drawingml/2006/main" noGrp="1"/>
+          </p:cNvSpPr>
+          <p:nvPr/>
+        </p:nvSpPr>
+        <p:spPr>
+          <a:xfrm xmlns:a="http://schemas.openxmlformats.org/drawingml/2006/main">
+            <a:off x="685800" y="657225"/>
+            <a:ext cx="10572750" cy="552450"/>
+          </a:xfrm>
+          <a:prstGeom xmlns:a="http://schemas.openxmlformats.org/drawingml/2006/main" prst="rect">
+            <a:avLst/>
+          </a:prstGeom>
+          <a:noFill xmlns:a="http://schemas.openxmlformats.org/drawingml/2006/main"/>
+          <a:ln xmlns:a="http://schemas.openxmlformats.org/drawingml/2006/main" w="0">
+            <a:noFill/>
+            <a:prstDash val="solid"/>
+          </a:ln>
+        </p:spPr>
+        <p:txBody>
+          <a:bodyPr xmlns:a="http://schemas.openxmlformats.org/drawingml/2006/main" wrap="none" lIns="0" tIns="0" rIns="0" bIns="0" anchor="t">
+            <a:noAutofit/>
+          </a:bodyPr>
+          <a:lstStyle xmlns:a="http://schemas.openxmlformats.org/drawingml/2006/main"/>
+          <a:p xmlns:a="http://schemas.openxmlformats.org/drawingml/2006/main">
+            <a:pPr algn="l">
+              <a:lnSpc>
+                <a:spcPct val="100000"/>
+              </a:lnSpc>
+              <a:buNone/>
+              <a:defRPr sz="3525" b="0">
+                <a:solidFill>
+                  <a:srgbClr val="12304A"/>
+                </a:solidFill>
+                <a:latin typeface="Calibri Light"/>
+                <a:ea typeface="Calibri Light"/>
+                <a:cs typeface="Calibri Light"/>
+              </a:defRPr>
+            </a:pPr>
+            <a:r>
+              <a:rPr sz="3525" b="0">
+                <a:solidFill>
+                  <a:srgbClr val="12304A"/>
+                </a:solidFill>
+                <a:latin typeface="Calibri Light"/>
+                <a:ea typeface="Calibri Light"/>
+                <a:cs typeface="Calibri Light"/>
+              </a:rPr>
+              <a:t>Upper-middle saving falls; the top 1% stays volatile</a:t>
+            </a:r>
+          </a:p>
+        </p:txBody>
+      </p:sp>
+      <p:sp>
+        <p:nvSpPr>
+          <p:cNvPr id="4" name="title-rule-4">
+            <a:extLst xmlns:a="http://schemas.openxmlformats.org/drawingml/2006/main">
+              <a:ext uri="{FF2B5EF4-FFF2-40B4-BE49-F238E27FC236}">
+                <a16:creationId xmlns:a16="http://schemas.microsoft.com/office/drawing/2014/main" id="{B937DE71-60F9-4EA0-8DBE-8BD108413904}"/>
+              </a:ext>
+            </a:extLst>
+          </p:cNvPr>
+          <p:cNvSpPr>
+            <a:spLocks xmlns:a="http://schemas.openxmlformats.org/drawingml/2006/main" noGrp="1"/>
+          </p:cNvSpPr>
+          <p:nvPr/>
+        </p:nvSpPr>
+        <p:spPr>
+          <a:xfrm xmlns:a="http://schemas.openxmlformats.org/drawingml/2006/main">
+            <a:off x="685800" y="1285875"/>
+            <a:ext cx="10820400" cy="28575"/>
+          </a:xfrm>
+          <a:prstGeom xmlns:a="http://schemas.openxmlformats.org/drawingml/2006/main" prst="rect">
+            <a:avLst/>
+          </a:prstGeom>
+          <a:solidFill xmlns:a="http://schemas.openxmlformats.org/drawingml/2006/main">
+            <a:srgbClr val="C85200"/>
+          </a:solidFill>
+          <a:ln xmlns:a="http://schemas.openxmlformats.org/drawingml/2006/main" w="0">
+            <a:noFill/>
+            <a:prstDash val="solid"/>
+          </a:ln>
+        </p:spPr>
+      </p:sp>
+      <p:sp>
+        <p:nvSpPr>
+          <p:cNvPr id="6" name="unveiling-callout">
+            <a:extLst xmlns:a="http://schemas.openxmlformats.org/drawingml/2006/main">
+              <a:ext uri="{FF2B5EF4-FFF2-40B4-BE49-F238E27FC236}">
+                <a16:creationId xmlns:a16="http://schemas.microsoft.com/office/drawing/2014/main" id="{46BEFB9F-3CE7-4B0F-B11B-8442C71F68B6}"/>
+              </a:ext>
+            </a:extLst>
+          </p:cNvPr>
+          <p:cNvSpPr>
+            <a:spLocks xmlns:a="http://schemas.openxmlformats.org/drawingml/2006/main" noGrp="1"/>
+          </p:cNvSpPr>
+          <p:nvPr/>
+        </p:nvSpPr>
+        <p:spPr>
+          <a:xfrm xmlns:a="http://schemas.openxmlformats.org/drawingml/2006/main">
+            <a:off x="9096375" y="1809750"/>
+            <a:ext cx="2333625" cy="2724150"/>
+          </a:xfrm>
+          <a:prstGeom xmlns:a="http://schemas.openxmlformats.org/drawingml/2006/main" prst="rect">
+            <a:avLst/>
+          </a:prstGeom>
+          <a:solidFill xmlns:a="http://schemas.openxmlformats.org/drawingml/2006/main">
+            <a:srgbClr val="EAF2F7"/>
+          </a:solidFill>
+          <a:ln xmlns:a="http://schemas.openxmlformats.org/drawingml/2006/main" w="0">
+            <a:noFill/>
+            <a:prstDash val="solid"/>
+          </a:ln>
+        </p:spPr>
+      </p:sp>
+      <p:sp>
+        <p:nvSpPr>
+          <p:cNvPr id="7" name="unveiling-callout-head">
+            <a:extLst xmlns:a="http://schemas.openxmlformats.org/drawingml/2006/main">
+              <a:ext uri="{FF2B5EF4-FFF2-40B4-BE49-F238E27FC236}">
+                <a16:creationId xmlns:a16="http://schemas.microsoft.com/office/drawing/2014/main" id="{F66C261D-099D-4A04-A8D3-9BB759A6F493}"/>
+              </a:ext>
+            </a:extLst>
+          </p:cNvPr>
+          <p:cNvSpPr>
+            <a:spLocks xmlns:a="http://schemas.openxmlformats.org/drawingml/2006/main" noGrp="1"/>
+          </p:cNvSpPr>
+          <p:nvPr/>
+        </p:nvSpPr>
+        <p:spPr>
+          <a:xfrm xmlns:a="http://schemas.openxmlformats.org/drawingml/2006/main">
+            <a:off x="9315450" y="2038350"/>
+            <a:ext cx="1924050" cy="342900"/>
+          </a:xfrm>
+          <a:prstGeom xmlns:a="http://schemas.openxmlformats.org/drawingml/2006/main" prst="rect">
+            <a:avLst/>
+          </a:prstGeom>
+          <a:noFill xmlns:a="http://schemas.openxmlformats.org/drawingml/2006/main"/>
+          <a:ln xmlns:a="http://schemas.openxmlformats.org/drawingml/2006/main" w="0">
+            <a:noFill/>
+            <a:prstDash val="solid"/>
+          </a:ln>
+        </p:spPr>
+        <p:txBody>
+          <a:bodyPr xmlns:a="http://schemas.openxmlformats.org/drawingml/2006/main" wrap="square" lIns="0" tIns="0" rIns="0" bIns="0" anchor="t">
+            <a:noAutofit/>
+          </a:bodyPr>
+          <a:lstStyle xmlns:a="http://schemas.openxmlformats.org/drawingml/2006/main"/>
+          <a:p xmlns:a="http://schemas.openxmlformats.org/drawingml/2006/main">
+            <a:pPr algn="l">
+              <a:lnSpc>
+                <a:spcPct val="100000"/>
+              </a:lnSpc>
+              <a:buNone/>
+              <a:defRPr sz="1650" b="1">
+                <a:solidFill>
+                  <a:srgbClr val="1170AA"/>
+                </a:solidFill>
+                <a:latin typeface="Calibri"/>
+                <a:ea typeface="Calibri"/>
+                <a:cs typeface="Calibri"/>
+              </a:defRPr>
+            </a:pPr>
+            <a:r>
+              <a:rPr sz="1650" b="1">
+                <a:solidFill>
+                  <a:srgbClr val="1170AA"/>
+                </a:solidFill>
+                <a:latin typeface="Calibri"/>
+                <a:ea typeface="Calibri"/>
+                <a:cs typeface="Calibri"/>
+              </a:rPr>
+              <a:t>Five-year rates</a:t>
+            </a:r>
+          </a:p>
+        </p:txBody>
+      </p:sp>
+      <p:sp>
+        <p:nvSpPr>
+          <p:cNvPr id="8" name="unveiling-top1">
+            <a:extLst xmlns:a="http://schemas.openxmlformats.org/drawingml/2006/main">
+              <a:ext uri="{FF2B5EF4-FFF2-40B4-BE49-F238E27FC236}">
+                <a16:creationId xmlns:a16="http://schemas.microsoft.com/office/drawing/2014/main" id="{1E2D59D0-34FC-4666-9356-6AC891D98394}"/>
+              </a:ext>
+            </a:extLst>
+          </p:cNvPr>
+          <p:cNvSpPr>
+            <a:spLocks xmlns:a="http://schemas.openxmlformats.org/drawingml/2006/main" noGrp="1"/>
+          </p:cNvSpPr>
+          <p:nvPr/>
+        </p:nvSpPr>
+        <p:spPr>
+          <a:xfrm xmlns:a="http://schemas.openxmlformats.org/drawingml/2006/main">
+            <a:off x="9315450" y="2590800"/>
+            <a:ext cx="1924050" cy="419100"/>
+          </a:xfrm>
+          <a:prstGeom xmlns:a="http://schemas.openxmlformats.org/drawingml/2006/main" prst="rect">
+            <a:avLst/>
+          </a:prstGeom>
+          <a:noFill xmlns:a="http://schemas.openxmlformats.org/drawingml/2006/main"/>
+          <a:ln xmlns:a="http://schemas.openxmlformats.org/drawingml/2006/main" w="0">
+            <a:noFill/>
+            <a:prstDash val="solid"/>
+          </a:ln>
+        </p:spPr>
+        <p:txBody>
+          <a:bodyPr xmlns:a="http://schemas.openxmlformats.org/drawingml/2006/main" wrap="square" lIns="0" tIns="0" rIns="0" bIns="0" anchor="t">
+            <a:noAutofit/>
+          </a:bodyPr>
+          <a:lstStyle xmlns:a="http://schemas.openxmlformats.org/drawingml/2006/main"/>
+          <a:p xmlns:a="http://schemas.openxmlformats.org/drawingml/2006/main">
+            <a:pPr algn="l">
+              <a:lnSpc>
+                <a:spcPct val="100000"/>
+              </a:lnSpc>
+              <a:buNone/>
+              <a:defRPr sz="2775" b="1">
+                <a:solidFill>
+                  <a:srgbClr val="12304A"/>
+                </a:solidFill>
+                <a:latin typeface="Calibri"/>
+                <a:ea typeface="Calibri"/>
+                <a:cs typeface="Calibri"/>
+              </a:defRPr>
+            </a:pPr>
+            <a:r>
+              <a:rPr sz="2175" b="1">
+                <a:solidFill>
+                  <a:srgbClr val="12304A"/>
+                </a:solidFill>
+                <a:latin typeface="Calibri"/>
+                <a:ea typeface="Calibri"/>
+                <a:cs typeface="Calibri"/>
+              </a:rPr>
+              <a:t>20.1% → 6.1%</a:t>
+            </a:r>
+          </a:p>
+        </p:txBody>
+      </p:sp>
+      <p:sp>
+        <p:nvSpPr>
+          <p:cNvPr id="9" name="unveiling-top1-label">
+            <a:extLst xmlns:a="http://schemas.openxmlformats.org/drawingml/2006/main">
+              <a:ext uri="{FF2B5EF4-FFF2-40B4-BE49-F238E27FC236}">
+                <a16:creationId xmlns:a16="http://schemas.microsoft.com/office/drawing/2014/main" id="{6E6C2350-D9B3-4A9E-AD6E-63D6413706CD}"/>
+              </a:ext>
+            </a:extLst>
+          </p:cNvPr>
+          <p:cNvSpPr>
+            <a:spLocks xmlns:a="http://schemas.openxmlformats.org/drawingml/2006/main" noGrp="1"/>
+          </p:cNvSpPr>
+          <p:nvPr/>
+        </p:nvSpPr>
+        <p:spPr>
+          <a:xfrm xmlns:a="http://schemas.openxmlformats.org/drawingml/2006/main">
+            <a:off x="9315450" y="3038475"/>
+            <a:ext cx="1924050" cy="266700"/>
+          </a:xfrm>
+          <a:prstGeom xmlns:a="http://schemas.openxmlformats.org/drawingml/2006/main" prst="rect">
+            <a:avLst/>
+          </a:prstGeom>
+          <a:noFill xmlns:a="http://schemas.openxmlformats.org/drawingml/2006/main"/>
+          <a:ln xmlns:a="http://schemas.openxmlformats.org/drawingml/2006/main" w="0">
+            <a:noFill/>
+            <a:prstDash val="solid"/>
+          </a:ln>
+        </p:spPr>
+        <p:txBody>
+          <a:bodyPr xmlns:a="http://schemas.openxmlformats.org/drawingml/2006/main" wrap="square" lIns="0" tIns="0" rIns="0" bIns="0" anchor="t">
+            <a:noAutofit/>
+          </a:bodyPr>
+          <a:lstStyle xmlns:a="http://schemas.openxmlformats.org/drawingml/2006/main"/>
+          <a:p xmlns:a="http://schemas.openxmlformats.org/drawingml/2006/main">
+            <a:pPr algn="l">
+              <a:lnSpc>
+                <a:spcPct val="100000"/>
+              </a:lnSpc>
+              <a:buNone/>
+              <a:defRPr sz="1500" b="0">
+                <a:solidFill>
+                  <a:srgbClr val="53616E"/>
+                </a:solidFill>
+                <a:latin typeface="Calibri"/>
+                <a:ea typeface="Calibri"/>
+                <a:cs typeface="Calibri"/>
+              </a:defRPr>
+            </a:pPr>
+            <a:r>
+              <a:rPr sz="1200" b="0">
+                <a:solidFill>
+                  <a:srgbClr val="53616E"/>
+                </a:solidFill>
+                <a:latin typeface="Calibri"/>
+                <a:ea typeface="Calibri"/>
+                <a:cs typeface="Calibri"/>
+              </a:rPr>
+              <a:t>80th pct.: 1982 → 2016</a:t>
+            </a:r>
+          </a:p>
+        </p:txBody>
+      </p:sp>
+      <p:sp>
+        <p:nvSpPr>
+          <p:cNvPr id="10" name="unveiling-next40">
+            <a:extLst xmlns:a="http://schemas.openxmlformats.org/drawingml/2006/main">
+              <a:ext uri="{FF2B5EF4-FFF2-40B4-BE49-F238E27FC236}">
+                <a16:creationId xmlns:a16="http://schemas.microsoft.com/office/drawing/2014/main" id="{A59386EE-960A-49E3-B63F-D6D6A0076EBC}"/>
+              </a:ext>
+            </a:extLst>
+          </p:cNvPr>
+          <p:cNvSpPr>
+            <a:spLocks xmlns:a="http://schemas.openxmlformats.org/drawingml/2006/main" noGrp="1"/>
+          </p:cNvSpPr>
+          <p:nvPr/>
+        </p:nvSpPr>
+        <p:spPr>
+          <a:xfrm xmlns:a="http://schemas.openxmlformats.org/drawingml/2006/main">
+            <a:off x="9315450" y="3495675"/>
+            <a:ext cx="1924050" cy="419100"/>
+          </a:xfrm>
+          <a:prstGeom xmlns:a="http://schemas.openxmlformats.org/drawingml/2006/main" prst="rect">
+            <a:avLst/>
+          </a:prstGeom>
+          <a:noFill xmlns:a="http://schemas.openxmlformats.org/drawingml/2006/main"/>
+          <a:ln xmlns:a="http://schemas.openxmlformats.org/drawingml/2006/main" w="0">
+            <a:noFill/>
+            <a:prstDash val="solid"/>
+          </a:ln>
+        </p:spPr>
+        <p:txBody>
+          <a:bodyPr xmlns:a="http://schemas.openxmlformats.org/drawingml/2006/main" wrap="square" lIns="0" tIns="0" rIns="0" bIns="0" anchor="t">
+            <a:noAutofit/>
+          </a:bodyPr>
+          <a:lstStyle xmlns:a="http://schemas.openxmlformats.org/drawingml/2006/main"/>
+          <a:p xmlns:a="http://schemas.openxmlformats.org/drawingml/2006/main">
+            <a:pPr algn="l">
+              <a:lnSpc>
+                <a:spcPct val="100000"/>
+              </a:lnSpc>
+              <a:buNone/>
+              <a:defRPr sz="2775" b="1">
+                <a:solidFill>
+                  <a:srgbClr val="12304A"/>
+                </a:solidFill>
+                <a:latin typeface="Calibri"/>
+                <a:ea typeface="Calibri"/>
+                <a:cs typeface="Calibri"/>
+              </a:defRPr>
+            </a:pPr>
+            <a:r>
+              <a:rPr sz="2175" b="1">
+                <a:solidFill>
+                  <a:srgbClr val="12304A"/>
+                </a:solidFill>
+                <a:latin typeface="Calibri"/>
+                <a:ea typeface="Calibri"/>
+                <a:cs typeface="Calibri"/>
+              </a:rPr>
+              <a:t>68.5% peak</a:t>
+            </a:r>
+          </a:p>
+        </p:txBody>
+      </p:sp>
+      <p:sp>
+        <p:nvSpPr>
+          <p:cNvPr id="11" name="unveiling-next40-label">
+            <a:extLst xmlns:a="http://schemas.openxmlformats.org/drawingml/2006/main">
+              <a:ext uri="{FF2B5EF4-FFF2-40B4-BE49-F238E27FC236}">
+                <a16:creationId xmlns:a16="http://schemas.microsoft.com/office/drawing/2014/main" id="{F774C9D0-7893-4A1F-A5E2-A5D98AF74A9F}"/>
+              </a:ext>
+            </a:extLst>
+          </p:cNvPr>
+          <p:cNvSpPr>
+            <a:spLocks xmlns:a="http://schemas.openxmlformats.org/drawingml/2006/main" noGrp="1"/>
+          </p:cNvSpPr>
+          <p:nvPr/>
+        </p:nvSpPr>
+        <p:spPr>
+          <a:xfrm xmlns:a="http://schemas.openxmlformats.org/drawingml/2006/main">
+            <a:off x="9315450" y="3943350"/>
+            <a:ext cx="1924050" cy="266700"/>
+          </a:xfrm>
+          <a:prstGeom xmlns:a="http://schemas.openxmlformats.org/drawingml/2006/main" prst="rect">
+            <a:avLst/>
+          </a:prstGeom>
+          <a:noFill xmlns:a="http://schemas.openxmlformats.org/drawingml/2006/main"/>
+          <a:ln xmlns:a="http://schemas.openxmlformats.org/drawingml/2006/main" w="0">
+            <a:noFill/>
+            <a:prstDash val="solid"/>
+          </a:ln>
+        </p:spPr>
+        <p:txBody>
+          <a:bodyPr xmlns:a="http://schemas.openxmlformats.org/drawingml/2006/main" wrap="square" lIns="0" tIns="0" rIns="0" bIns="0" anchor="t">
+            <a:noAutofit/>
+          </a:bodyPr>
+          <a:lstStyle xmlns:a="http://schemas.openxmlformats.org/drawingml/2006/main"/>
+          <a:p xmlns:a="http://schemas.openxmlformats.org/drawingml/2006/main">
+            <a:pPr algn="l">
+              <a:lnSpc>
+                <a:spcPct val="100000"/>
+              </a:lnSpc>
+              <a:buNone/>
+              <a:defRPr sz="1500" b="0">
+                <a:solidFill>
+                  <a:srgbClr val="53616E"/>
+                </a:solidFill>
+                <a:latin typeface="Calibri"/>
+                <a:ea typeface="Calibri"/>
+                <a:cs typeface="Calibri"/>
+              </a:defRPr>
+            </a:pPr>
+            <a:r>
+              <a:rPr sz="1200" b="0">
+                <a:solidFill>
+                  <a:srgbClr val="53616E"/>
+                </a:solidFill>
+                <a:latin typeface="Calibri"/>
+                <a:ea typeface="Calibri"/>
+                <a:cs typeface="Calibri"/>
+              </a:rPr>
+              <a:t>Top 1% · 2008 window</a:t>
+            </a:r>
+          </a:p>
+        </p:txBody>
+      </p:sp>
+      <p:sp>
+        <p:nvSpPr>
+          <p:cNvPr id="12" name="implication-band-4">
+            <a:extLst xmlns:a="http://schemas.openxmlformats.org/drawingml/2006/main">
+              <a:ext uri="{FF2B5EF4-FFF2-40B4-BE49-F238E27FC236}">
+                <a16:creationId xmlns:a16="http://schemas.microsoft.com/office/drawing/2014/main" id="{F99C7C96-A626-4ED9-AA36-1DFFFFE09157}"/>
+              </a:ext>
+            </a:extLst>
+          </p:cNvPr>
+          <p:cNvSpPr>
+            <a:spLocks xmlns:a="http://schemas.openxmlformats.org/drawingml/2006/main" noGrp="1"/>
+          </p:cNvSpPr>
+          <p:nvPr/>
+        </p:nvSpPr>
+        <p:spPr>
+          <a:xfrm xmlns:a="http://schemas.openxmlformats.org/drawingml/2006/main">
+            <a:off x="685800" y="5638800"/>
+            <a:ext cx="10820400" cy="590550"/>
+          </a:xfrm>
+          <a:prstGeom xmlns:a="http://schemas.openxmlformats.org/drawingml/2006/main" prst="rect">
+            <a:avLst/>
+          </a:prstGeom>
+          <a:solidFill xmlns:a="http://schemas.openxmlformats.org/drawingml/2006/main">
+            <a:srgbClr val="EAF2F7"/>
+          </a:solidFill>
+          <a:ln xmlns:a="http://schemas.openxmlformats.org/drawingml/2006/main" w="0">
+            <a:noFill/>
+            <a:prstDash val="solid"/>
+          </a:ln>
+        </p:spPr>
+      </p:sp>
+      <p:sp>
+        <p:nvSpPr>
+          <p:cNvPr id="13" name="implication-4">
+            <a:extLst xmlns:a="http://schemas.openxmlformats.org/drawingml/2006/main">
+              <a:ext uri="{FF2B5EF4-FFF2-40B4-BE49-F238E27FC236}">
+                <a16:creationId xmlns:a16="http://schemas.microsoft.com/office/drawing/2014/main" id="{7927E323-74AF-4077-B4ED-E330091CEBD3}"/>
+              </a:ext>
+            </a:extLst>
+          </p:cNvPr>
+          <p:cNvSpPr>
+            <a:spLocks xmlns:a="http://schemas.openxmlformats.org/drawingml/2006/main" noGrp="1"/>
+          </p:cNvSpPr>
+          <p:nvPr/>
+        </p:nvSpPr>
+        <p:spPr>
+          <a:xfrm xmlns:a="http://schemas.openxmlformats.org/drawingml/2006/main">
+            <a:off x="895350" y="5781675"/>
+            <a:ext cx="10401300" cy="323850"/>
+          </a:xfrm>
+          <a:prstGeom xmlns:a="http://schemas.openxmlformats.org/drawingml/2006/main" prst="rect">
+            <a:avLst/>
+          </a:prstGeom>
+          <a:noFill xmlns:a="http://schemas.openxmlformats.org/drawingml/2006/main"/>
+          <a:ln xmlns:a="http://schemas.openxmlformats.org/drawingml/2006/main" w="0">
+            <a:noFill/>
+            <a:prstDash val="solid"/>
+          </a:ln>
+        </p:spPr>
+        <p:txBody>
+          <a:bodyPr xmlns:a="http://schemas.openxmlformats.org/drawingml/2006/main" wrap="square" lIns="0" tIns="0" rIns="0" bIns="0" anchor="ctr">
+            <a:noAutofit/>
+          </a:bodyPr>
+          <a:lstStyle xmlns:a="http://schemas.openxmlformats.org/drawingml/2006/main"/>
+          <a:p xmlns:a="http://schemas.openxmlformats.org/drawingml/2006/main">
+            <a:pPr algn="l">
+              <a:lnSpc>
+                <a:spcPct val="100000"/>
+              </a:lnSpc>
+              <a:buNone/>
+              <a:defRPr sz="1725" b="1">
+                <a:solidFill>
+                  <a:srgbClr val="12304A"/>
+                </a:solidFill>
+                <a:latin typeface="Calibri"/>
+                <a:ea typeface="Calibri"/>
+                <a:cs typeface="Calibri"/>
+              </a:defRPr>
+            </a:pPr>
+            <a:r>
+              <a:rPr sz="1725" b="1">
+                <a:solidFill>
+                  <a:srgbClr val="12304A"/>
+                </a:solidFill>
+                <a:latin typeface="Calibri"/>
+                <a:ea typeface="Calibri"/>
+                <a:cs typeface="Calibri"/>
+              </a:rPr>
+              <a:t>The paper’s two periods compress heterogeneous dynamics: upper-middle rates trend down while the top 1% remains highly volatile.</a:t>
+            </a:r>
+          </a:p>
+        </p:txBody>
+      </p:sp>
+      <p:sp>
+        <p:nvSpPr>
+          <p:cNvPr id="14" name="source-4">
+            <a:extLst xmlns:a="http://schemas.openxmlformats.org/drawingml/2006/main">
+              <a:ext uri="{FF2B5EF4-FFF2-40B4-BE49-F238E27FC236}">
+                <a16:creationId xmlns:a16="http://schemas.microsoft.com/office/drawing/2014/main" id="{537BBD31-6288-48F6-9A86-03C97EDBCA95}"/>
+              </a:ext>
+            </a:extLst>
+          </p:cNvPr>
+          <p:cNvSpPr>
+            <a:spLocks xmlns:a="http://schemas.openxmlformats.org/drawingml/2006/main" noGrp="1"/>
+          </p:cNvSpPr>
+          <p:nvPr/>
+        </p:nvSpPr>
+        <p:spPr>
+          <a:xfrm xmlns:a="http://schemas.openxmlformats.org/drawingml/2006/main">
+            <a:off x="685800" y="6381750"/>
+            <a:ext cx="10820400" cy="228600"/>
+          </a:xfrm>
+          <a:prstGeom xmlns:a="http://schemas.openxmlformats.org/drawingml/2006/main" prst="rect">
+            <a:avLst/>
+          </a:prstGeom>
+          <a:noFill xmlns:a="http://schemas.openxmlformats.org/drawingml/2006/main"/>
+          <a:ln xmlns:a="http://schemas.openxmlformats.org/drawingml/2006/main" w="0">
+            <a:noFill/>
+            <a:prstDash val="solid"/>
+          </a:ln>
+        </p:spPr>
+        <p:txBody>
+          <a:bodyPr xmlns:a="http://schemas.openxmlformats.org/drawingml/2006/main" wrap="square" lIns="0" tIns="0" rIns="0" bIns="0" anchor="t">
+            <a:noAutofit/>
+          </a:bodyPr>
+          <a:lstStyle xmlns:a="http://schemas.openxmlformats.org/drawingml/2006/main"/>
+          <a:p xmlns:a="http://schemas.openxmlformats.org/drawingml/2006/main">
+            <a:pPr algn="l">
+              <a:lnSpc>
+                <a:spcPct val="100000"/>
+              </a:lnSpc>
+              <a:buNone/>
+              <a:defRPr sz="1200" b="0">
+                <a:solidFill>
+                  <a:srgbClr val="53616E"/>
+                </a:solidFill>
+                <a:latin typeface="Calibri"/>
+                <a:ea typeface="Calibri"/>
+                <a:cs typeface="Calibri"/>
+              </a:defRPr>
+            </a:pPr>
+            <a:r>
+              <a:rPr sz="1200" b="0">
+                <a:solidFill>
+                  <a:srgbClr val="53616E"/>
+                </a:solidFill>
+                <a:latin typeface="Calibri"/>
+                <a:ea typeface="Calibri"/>
+                <a:cs typeface="Calibri"/>
+              </a:rPr>
+              <a:t>Source: trailing five-year means of the same annual Figure 6 net saving rate; vertical line marks 1982.</a:t>
+            </a:r>
+          </a:p>
+        </p:txBody>
+      </p:sp>
+      <p:pic>
+        <p:nvPicPr>
+          <p:cNvPr id="30" name=""/>
+          <p:cNvPicPr>
+            <a:picLocks xmlns:a="http://schemas.openxmlformats.org/drawingml/2006/main" noChangeAspect="1"/>
+          </p:cNvPicPr>
+          <p:nvPr/>
+        </p:nvPicPr>
+        <p:blipFill>
+          <a:blip xmlns:r="http://schemas.openxmlformats.org/officeDocument/2006/relationships" xmlns:a="http://schemas.openxmlformats.org/drawingml/2006/main" r:embed="Re82834e4f9704d6c"/>
+          <a:stretch xmlns:a="http://schemas.openxmlformats.org/drawingml/2006/main"/>
+        </p:blipFill>
+        <p:spPr>
+          <a:xfrm xmlns:a="http://schemas.openxmlformats.org/drawingml/2006/main">
+            <a:off x="1599474" y="1504950"/>
+            <a:ext cx="6345101" cy="3905250"/>
+          </a:xfrm>
+          <a:prstGeom xmlns:a="http://schemas.openxmlformats.org/drawingml/2006/main" prst="rect">
+            <a:avLst/>
+          </a:prstGeom>
+        </p:spPr>
+      </p:pic>
+    </p:spTree>
+    <p:extLst>
+      <p:ext uri="{BB962C8B-B14F-4D97-AF65-F5344CB8AC3E}">
+        <p14:creationId xmlns:p14="http://schemas.microsoft.com/office/powerpoint/2010/main" val="667014454"/>
+      </p:ext>
+    </p:extLst>
+  </p:cSld>
+</p:sld>
+</file>
+
+<file path=ppt/slides/slide7.xml><?xml version="1.0" encoding="utf-8"?>
+<p:sld xmlns:p="http://schemas.openxmlformats.org/presentationml/2006/main">
+  <p:cSld>
+    <p:bg>
+      <p:bgPr>
+        <a:solidFill xmlns:a="http://schemas.openxmlformats.org/drawingml/2006/main">
+          <a:srgbClr val="FFFFFF"/>
+        </a:solidFill>
+      </p:bgPr>
+    </p:bg>
+    <p:spTree>
+      <p:nvGrpSpPr>
+        <p:cNvPr id="1" name=""/>
+        <p:cNvGrpSpPr/>
+        <p:nvPr/>
+      </p:nvGrpSpPr>
+      <p:grpSpPr>
+        <a:xfrm xmlns:a="http://schemas.openxmlformats.org/drawingml/2006/main"/>
+      </p:grpSpPr>
+      <p:sp>
+        <p:nvSpPr>
+          <p:cNvPr id="19" name="eyebrow-5">
+            <a:extLst xmlns:a="http://schemas.openxmlformats.org/drawingml/2006/main">
+              <a:ext uri="{FF2B5EF4-FFF2-40B4-BE49-F238E27FC236}">
+                <a16:creationId xmlns:a16="http://schemas.microsoft.com/office/drawing/2014/main" id="{B7E82457-90C6-4314-BA41-630C35AF3260}"/>
+              </a:ext>
+            </a:extLst>
+          </p:cNvPr>
+          <p:cNvSpPr>
+            <a:spLocks xmlns:a="http://schemas.openxmlformats.org/drawingml/2006/main" noGrp="1"/>
+          </p:cNvSpPr>
+          <p:nvPr/>
+        </p:nvSpPr>
+        <p:spPr>
+          <a:xfrm xmlns:a="http://schemas.openxmlformats.org/drawingml/2006/main">
+            <a:off x="685800" y="323850"/>
+            <a:ext cx="6667500" cy="228600"/>
+          </a:xfrm>
+          <a:prstGeom xmlns:a="http://schemas.openxmlformats.org/drawingml/2006/main" prst="rect">
+            <a:avLst/>
+          </a:prstGeom>
+          <a:noFill xmlns:a="http://schemas.openxmlformats.org/drawingml/2006/main"/>
+          <a:ln xmlns:a="http://schemas.openxmlformats.org/drawingml/2006/main" w="0">
+            <a:noFill/>
+            <a:prstDash val="solid"/>
+          </a:ln>
+        </p:spPr>
+        <p:txBody>
+          <a:bodyPr xmlns:a="http://schemas.openxmlformats.org/drawingml/2006/main" wrap="square" lIns="0" tIns="0" rIns="0" bIns="0" anchor="t">
+            <a:noAutofit/>
+          </a:bodyPr>
+          <a:lstStyle xmlns:a="http://schemas.openxmlformats.org/drawingml/2006/main"/>
+          <a:p xmlns:a="http://schemas.openxmlformats.org/drawingml/2006/main">
+            <a:pPr algn="l">
+              <a:lnSpc>
+                <a:spcPct val="100000"/>
+              </a:lnSpc>
+              <a:buNone/>
+              <a:defRPr sz="1200" b="1">
+                <a:solidFill>
+                  <a:srgbClr val="C85200"/>
+                </a:solidFill>
+                <a:latin typeface="Calibri"/>
+                <a:ea typeface="Calibri"/>
+                <a:cs typeface="Calibri"/>
+              </a:defRPr>
+            </a:pPr>
+            <a:r>
+              <a:rPr sz="1200" b="1">
+                <a:solidFill>
+                  <a:srgbClr val="C85200"/>
+                </a:solidFill>
+                <a:latin typeface="Calibri"/>
+                <a:ea typeface="Calibri"/>
+                <a:cs typeface="Calibri"/>
+              </a:rPr>
+              <a:t>RESEARCH EXTENSION  ·  PRELIMINARY EVIDENCE</a:t>
+            </a:r>
+          </a:p>
+        </p:txBody>
+      </p:sp>
+      <p:sp>
+        <p:nvSpPr>
+          <p:cNvPr id="2" name="page-5">
+            <a:extLst xmlns:a="http://schemas.openxmlformats.org/drawingml/2006/main">
+              <a:ext uri="{FF2B5EF4-FFF2-40B4-BE49-F238E27FC236}">
+                <a16:creationId xmlns:a16="http://schemas.microsoft.com/office/drawing/2014/main" id="{632A8695-AB68-4847-9051-1E65BC22DF54}"/>
+              </a:ext>
+            </a:extLst>
+          </p:cNvPr>
+          <p:cNvSpPr>
+            <a:spLocks xmlns:a="http://schemas.openxmlformats.org/drawingml/2006/main" noGrp="1"/>
+          </p:cNvSpPr>
+          <p:nvPr/>
+        </p:nvSpPr>
+        <p:spPr>
+          <a:xfrm xmlns:a="http://schemas.openxmlformats.org/drawingml/2006/main">
+            <a:off x="11239500" y="314325"/>
+            <a:ext cx="266700" cy="228600"/>
+          </a:xfrm>
+          <a:prstGeom xmlns:a="http://schemas.openxmlformats.org/drawingml/2006/main" prst="rect">
+            <a:avLst/>
+          </a:prstGeom>
+          <a:noFill xmlns:a="http://schemas.openxmlformats.org/drawingml/2006/main"/>
+          <a:ln xmlns:a="http://schemas.openxmlformats.org/drawingml/2006/main" w="0">
+            <a:noFill/>
+            <a:prstDash val="solid"/>
+          </a:ln>
+        </p:spPr>
+        <p:txBody>
+          <a:bodyPr xmlns:a="http://schemas.openxmlformats.org/drawingml/2006/main" wrap="square" lIns="0" tIns="0" rIns="0" bIns="0" anchor="t">
+            <a:noAutofit/>
+          </a:bodyPr>
+          <a:lstStyle xmlns:a="http://schemas.openxmlformats.org/drawingml/2006/main"/>
+          <a:p xmlns:a="http://schemas.openxmlformats.org/drawingml/2006/main">
+            <a:pPr algn="r">
+              <a:lnSpc>
+                <a:spcPct val="100000"/>
+              </a:lnSpc>
+              <a:buNone/>
+              <a:defRPr sz="1200" b="0">
+                <a:solidFill>
+                  <a:srgbClr val="53616E"/>
+                </a:solidFill>
+                <a:latin typeface="Calibri"/>
+                <a:ea typeface="Calibri"/>
+                <a:cs typeface="Calibri"/>
+              </a:defRPr>
+            </a:pPr>
+            <a:r>
+              <a:rPr sz="1200" b="0">
+                <a:solidFill>
+                  <a:srgbClr val="53616E"/>
+                </a:solidFill>
+                <a:latin typeface="Calibri"/>
+                <a:ea typeface="Calibri"/>
+                <a:cs typeface="Calibri"/>
+              </a:rPr>
+              <a:t>07</a:t>
             </a:r>
           </a:p>
         </p:txBody>

</xml_diff>